<commit_message>
Reserve frontier-model slots: columns in the primary results table, report section 5.4.1, dedicated PPT slide
</commit_message>
<xml_diff>
--- a/docs/report/CA3_Presentation_Geometric_Consistency.pptx
+++ b/docs/report/CA3_Presentation_Geometric_Consistency.pptx
@@ -24,6 +24,7 @@
     <p:sldId id="272" r:id="rId24"/>
     <p:sldId id="273" r:id="rId25"/>
     <p:sldId id="274" r:id="rId26"/>
+    <p:sldId id="275" r:id="rId27"/>
   </p:sldIdLst>
   <p:sldSz cx="12191695" cy="6858000" type="screen4x3"/>
   <p:notesSz cx="6858000" cy="9144000"/>
@@ -1010,7 +1011,7 @@
           <a:lstStyle/>
           <a:p>
             <a:r>
-              <a:t>Have two images ready: one real photograph that passes, one generated image that fails.</a:t>
+              <a:t>If asked why frontier models are missing: no API access was available; the design anticipates them and the prompts are already content-matched.</a:t>
             </a:r>
           </a:p>
         </p:txBody>
@@ -1080,7 +1081,7 @@
           <a:lstStyle/>
           <a:p>
             <a:r>
-              <a:t>If asked for one sentence, use the line at the bottom.</a:t>
+              <a:t>Have two images ready: one real photograph that passes, one generated image that fails.</a:t>
             </a:r>
           </a:p>
         </p:txBody>
@@ -1150,7 +1151,7 @@
           <a:lstStyle/>
           <a:p>
             <a:r>
-              <a:t>Frontier models are the highest-value next step and need no new code.</a:t>
+              <a:t>If asked for one sentence, use the line at the bottom.</a:t>
             </a:r>
           </a:p>
         </p:txBody>
@@ -1220,7 +1221,7 @@
           <a:lstStyle/>
           <a:p>
             <a:r>
-              <a:t>Verify all reference details against publisher records before submission.</a:t>
+              <a:t>Frontier models are the highest-value next step and need no new code.</a:t>
             </a:r>
           </a:p>
         </p:txBody>
@@ -1291,6 +1292,76 @@
           <a:p>
             <a:r>
               <a:t>Emphasise that these are consequences of projective geometry, not statistical tendencies.</a:t>
+            </a:r>
+          </a:p>
+        </p:txBody>
+      </p:sp>
+      <p:sp>
+        <p:nvSpPr>
+          <p:cNvPr id="4" name="Slide Number Placeholder 3"/>
+          <p:cNvSpPr>
+            <a:spLocks noGrp="1"/>
+          </p:cNvSpPr>
+          <p:nvPr>
+            <p:ph type="sldNum" idx="5" sz="quarter"/>
+          </p:nvPr>
+        </p:nvSpPr>
+        <p:spPr/>
+      </p:sp>
+    </p:spTree>
+  </p:cSld>
+  <p:clrMapOvr>
+    <a:masterClrMapping/>
+  </p:clrMapOvr>
+</p:notes>
+</file>
+
+<file path=ppt/notesSlides/notesSlide20.xml><?xml version="1.0" encoding="utf-8"?>
+<p:notes xmlns:a="http://schemas.openxmlformats.org/drawingml/2006/main" xmlns:p="http://schemas.openxmlformats.org/presentationml/2006/main" xmlns:r="http://schemas.openxmlformats.org/officeDocument/2006/relationships">
+  <p:cSld>
+    <p:spTree>
+      <p:nvGrpSpPr>
+        <p:cNvPr id="1" name=""/>
+        <p:cNvGrpSpPr/>
+        <p:nvPr/>
+      </p:nvGrpSpPr>
+      <p:grpSpPr>
+        <a:xfrm>
+          <a:off x="0" y="0"/>
+          <a:ext cx="0" cy="0"/>
+          <a:chOff x="0" y="0"/>
+          <a:chExt cx="0" cy="0"/>
+        </a:xfrm>
+      </p:grpSpPr>
+      <p:sp>
+        <p:nvSpPr>
+          <p:cNvPr id="2" name="Slide Image Placeholder 1"/>
+          <p:cNvSpPr>
+            <a:spLocks noGrp="1"/>
+          </p:cNvSpPr>
+          <p:nvPr>
+            <p:ph type="sldImg" idx="2"/>
+          </p:nvPr>
+        </p:nvSpPr>
+        <p:spPr/>
+      </p:sp>
+      <p:sp>
+        <p:nvSpPr>
+          <p:cNvPr id="3" name="Notes Placeholder 2"/>
+          <p:cNvSpPr>
+            <a:spLocks noGrp="1"/>
+          </p:cNvSpPr>
+          <p:nvPr>
+            <p:ph type="body" idx="3" sz="quarter"/>
+          </p:nvPr>
+        </p:nvSpPr>
+        <p:spPr/>
+        <p:txBody>
+          <a:bodyPr/>
+          <a:lstStyle/>
+          <a:p>
+            <a:r>
+              <a:t>Verify all reference details against publisher records before submission.</a:t>
             </a:r>
           </a:p>
         </p:txBody>
@@ -7105,7 +7176,7 @@
         </p:nvGraphicFramePr>
         <p:xfrm>
           <a:off x="640080" y="1828800"/>
-          <a:ext cx="10908791" cy="2011680"/>
+          <a:ext cx="10908792" cy="2011680"/>
         </p:xfrm>
         <a:graphic>
           <a:graphicData uri="http://schemas.openxmlformats.org/drawingml/2006/table">
@@ -7114,11 +7185,13 @@
                 <a:tableStyleId>{5C22544A-7EE6-4342-B048-85BDC9FD1C3A}</a:tableStyleId>
               </a:tblPr>
               <a:tblGrid>
-                <a:gridCol w="3017520"/>
-                <a:gridCol w="2103120"/>
-                <a:gridCol w="2103120"/>
-                <a:gridCol w="1828800"/>
-                <a:gridCol w="1856231"/>
+                <a:gridCol w="2514600"/>
+                <a:gridCol w="1508760"/>
+                <a:gridCol w="1508760"/>
+                <a:gridCol w="1417320"/>
+                <a:gridCol w="1417320"/>
+                <a:gridCol w="1271016"/>
+                <a:gridCol w="1271016"/>
               </a:tblGrid>
               <a:tr h="502920">
                 <a:tc>
@@ -7127,7 +7200,7 @@
                     <a:lstStyle/>
                     <a:p>
                       <a:r>
-                        <a:rPr sz="1150" b="1">
+                        <a:rPr sz="1000" b="1">
                           <a:solidFill>
                             <a:srgbClr val="FFFFFF"/>
                           </a:solidFill>
@@ -7149,7 +7222,7 @@
                     <a:lstStyle/>
                     <a:p>
                       <a:r>
-                        <a:rPr sz="1150" b="1">
+                        <a:rPr sz="1000" b="1">
                           <a:solidFill>
                             <a:srgbClr val="FFFFFF"/>
                           </a:solidFill>
@@ -7171,7 +7244,7 @@
                     <a:lstStyle/>
                     <a:p>
                       <a:r>
-                        <a:rPr sz="1150" b="1">
+                        <a:rPr sz="1000" b="1">
                           <a:solidFill>
                             <a:srgbClr val="FFFFFF"/>
                           </a:solidFill>
@@ -7193,7 +7266,7 @@
                     <a:lstStyle/>
                     <a:p>
                       <a:r>
-                        <a:rPr sz="1150" b="1">
+                        <a:rPr sz="1000" b="1">
                           <a:solidFill>
                             <a:srgbClr val="FFFFFF"/>
                           </a:solidFill>
@@ -7215,13 +7288,57 @@
                     <a:lstStyle/>
                     <a:p>
                       <a:r>
-                        <a:rPr sz="1150" b="1">
+                        <a:rPr sz="1000" b="1">
                           <a:solidFill>
                             <a:srgbClr val="FFFFFF"/>
                           </a:solidFill>
                           <a:latin typeface="Calibri"/>
                         </a:rPr>
                         <a:t>SDXL</a:t>
+                      </a:r>
+                    </a:p>
+                  </a:txBody>
+                  <a:tcPr anchor="ctr">
+                    <a:solidFill>
+                      <a:srgbClr val="12263A"/>
+                    </a:solidFill>
+                  </a:tcPr>
+                </a:tc>
+                <a:tc>
+                  <a:txBody>
+                    <a:bodyPr/>
+                    <a:lstStyle/>
+                    <a:p>
+                      <a:r>
+                        <a:rPr sz="1000" b="1">
+                          <a:solidFill>
+                            <a:srgbClr val="FFFFFF"/>
+                          </a:solidFill>
+                          <a:latin typeface="Calibri"/>
+                        </a:rPr>
+                        <a:t>Gemini</a:t>
+                      </a:r>
+                    </a:p>
+                  </a:txBody>
+                  <a:tcPr anchor="ctr">
+                    <a:solidFill>
+                      <a:srgbClr val="12263A"/>
+                    </a:solidFill>
+                  </a:tcPr>
+                </a:tc>
+                <a:tc>
+                  <a:txBody>
+                    <a:bodyPr/>
+                    <a:lstStyle/>
+                    <a:p>
+                      <a:r>
+                        <a:rPr sz="1000" b="1">
+                          <a:solidFill>
+                            <a:srgbClr val="FFFFFF"/>
+                          </a:solidFill>
+                          <a:latin typeface="Calibri"/>
+                        </a:rPr>
+                        <a:t>GPT-image</a:t>
                       </a:r>
                     </a:p>
                   </a:txBody>
@@ -7239,7 +7356,7 @@
                     <a:lstStyle/>
                     <a:p>
                       <a:r>
-                        <a:rPr sz="1150">
+                        <a:rPr sz="1000">
                           <a:solidFill>
                             <a:srgbClr val="1A1A1A"/>
                           </a:solidFill>
@@ -7261,7 +7378,7 @@
                     <a:lstStyle/>
                     <a:p>
                       <a:r>
-                        <a:rPr sz="1150">
+                        <a:rPr sz="1000">
                           <a:solidFill>
                             <a:srgbClr val="1A1A1A"/>
                           </a:solidFill>
@@ -7283,7 +7400,7 @@
                     <a:lstStyle/>
                     <a:p>
                       <a:r>
-                        <a:rPr sz="1150">
+                        <a:rPr sz="1000">
                           <a:solidFill>
                             <a:srgbClr val="1A1A1A"/>
                           </a:solidFill>
@@ -7305,7 +7422,7 @@
                     <a:lstStyle/>
                     <a:p>
                       <a:r>
-                        <a:rPr sz="1150">
+                        <a:rPr sz="1000">
                           <a:solidFill>
                             <a:srgbClr val="1A1A1A"/>
                           </a:solidFill>
@@ -7327,13 +7444,57 @@
                     <a:lstStyle/>
                     <a:p>
                       <a:r>
-                        <a:rPr sz="1150">
+                        <a:rPr sz="1000">
                           <a:solidFill>
                             <a:srgbClr val="1A1A1A"/>
                           </a:solidFill>
                           <a:latin typeface="Calibri"/>
                         </a:rPr>
                         <a:t>112</a:t>
+                      </a:r>
+                    </a:p>
+                  </a:txBody>
+                  <a:tcPr anchor="ctr">
+                    <a:solidFill>
+                      <a:srgbClr val="FFFFFF"/>
+                    </a:solidFill>
+                  </a:tcPr>
+                </a:tc>
+                <a:tc>
+                  <a:txBody>
+                    <a:bodyPr/>
+                    <a:lstStyle/>
+                    <a:p>
+                      <a:r>
+                        <a:rPr sz="1000">
+                          <a:solidFill>
+                            <a:srgbClr val="1A1A1A"/>
+                          </a:solidFill>
+                          <a:latin typeface="Calibri"/>
+                        </a:rPr>
+                        <a:t>—</a:t>
+                      </a:r>
+                    </a:p>
+                  </a:txBody>
+                  <a:tcPr anchor="ctr">
+                    <a:solidFill>
+                      <a:srgbClr val="FFFFFF"/>
+                    </a:solidFill>
+                  </a:tcPr>
+                </a:tc>
+                <a:tc>
+                  <a:txBody>
+                    <a:bodyPr/>
+                    <a:lstStyle/>
+                    <a:p>
+                      <a:r>
+                        <a:rPr sz="1000">
+                          <a:solidFill>
+                            <a:srgbClr val="1A1A1A"/>
+                          </a:solidFill>
+                          <a:latin typeface="Calibri"/>
+                        </a:rPr>
+                        <a:t>—</a:t>
                       </a:r>
                     </a:p>
                   </a:txBody>
@@ -7351,7 +7512,7 @@
                     <a:lstStyle/>
                     <a:p>
                       <a:r>
-                        <a:rPr sz="1150">
+                        <a:rPr sz="1000">
                           <a:solidFill>
                             <a:srgbClr val="1A1A1A"/>
                           </a:solidFill>
@@ -7373,7 +7534,7 @@
                     <a:lstStyle/>
                     <a:p>
                       <a:r>
-                        <a:rPr sz="1150">
+                        <a:rPr sz="1000">
                           <a:solidFill>
                             <a:srgbClr val="1A1A1A"/>
                           </a:solidFill>
@@ -7395,7 +7556,7 @@
                     <a:lstStyle/>
                     <a:p>
                       <a:r>
-                        <a:rPr sz="1150">
+                        <a:rPr sz="1000">
                           <a:solidFill>
                             <a:srgbClr val="1A1A1A"/>
                           </a:solidFill>
@@ -7417,7 +7578,7 @@
                     <a:lstStyle/>
                     <a:p>
                       <a:r>
-                        <a:rPr sz="1150">
+                        <a:rPr sz="1000">
                           <a:solidFill>
                             <a:srgbClr val="1A1A1A"/>
                           </a:solidFill>
@@ -7439,13 +7600,57 @@
                     <a:lstStyle/>
                     <a:p>
                       <a:r>
-                        <a:rPr sz="1150">
+                        <a:rPr sz="1000">
                           <a:solidFill>
                             <a:srgbClr val="1A1A1A"/>
                           </a:solidFill>
                           <a:latin typeface="Calibri"/>
                         </a:rPr>
                         <a:t>0.355 [0.272, 0.529]</a:t>
+                      </a:r>
+                    </a:p>
+                  </a:txBody>
+                  <a:tcPr anchor="ctr">
+                    <a:solidFill>
+                      <a:srgbClr val="F4F6F8"/>
+                    </a:solidFill>
+                  </a:tcPr>
+                </a:tc>
+                <a:tc>
+                  <a:txBody>
+                    <a:bodyPr/>
+                    <a:lstStyle/>
+                    <a:p>
+                      <a:r>
+                        <a:rPr sz="1000">
+                          <a:solidFill>
+                            <a:srgbClr val="1A1A1A"/>
+                          </a:solidFill>
+                          <a:latin typeface="Calibri"/>
+                        </a:rPr>
+                        <a:t>pending</a:t>
+                      </a:r>
+                    </a:p>
+                  </a:txBody>
+                  <a:tcPr anchor="ctr">
+                    <a:solidFill>
+                      <a:srgbClr val="F4F6F8"/>
+                    </a:solidFill>
+                  </a:tcPr>
+                </a:tc>
+                <a:tc>
+                  <a:txBody>
+                    <a:bodyPr/>
+                    <a:lstStyle/>
+                    <a:p>
+                      <a:r>
+                        <a:rPr sz="1000">
+                          <a:solidFill>
+                            <a:srgbClr val="1A1A1A"/>
+                          </a:solidFill>
+                          <a:latin typeface="Calibri"/>
+                        </a:rPr>
+                        <a:t>pending</a:t>
                       </a:r>
                     </a:p>
                   </a:txBody>
@@ -7463,7 +7668,7 @@
                     <a:lstStyle/>
                     <a:p>
                       <a:r>
-                        <a:rPr sz="1150">
+                        <a:rPr sz="1000">
                           <a:solidFill>
                             <a:srgbClr val="1A1A1A"/>
                           </a:solidFill>
@@ -7485,7 +7690,7 @@
                     <a:lstStyle/>
                     <a:p>
                       <a:r>
-                        <a:rPr sz="1150">
+                        <a:rPr sz="1000">
                           <a:solidFill>
                             <a:srgbClr val="1A1A1A"/>
                           </a:solidFill>
@@ -7507,7 +7712,7 @@
                     <a:lstStyle/>
                     <a:p>
                       <a:r>
-                        <a:rPr sz="1150">
+                        <a:rPr sz="1000">
                           <a:solidFill>
                             <a:srgbClr val="1A1A1A"/>
                           </a:solidFill>
@@ -7529,7 +7734,7 @@
                     <a:lstStyle/>
                     <a:p>
                       <a:r>
-                        <a:rPr sz="1150">
+                        <a:rPr sz="1000">
                           <a:solidFill>
                             <a:srgbClr val="1A1A1A"/>
                           </a:solidFill>
@@ -7551,7 +7756,7 @@
                     <a:lstStyle/>
                     <a:p>
                       <a:r>
-                        <a:rPr sz="1150">
+                        <a:rPr sz="1000">
                           <a:solidFill>
                             <a:srgbClr val="1A1A1A"/>
                           </a:solidFill>
@@ -7567,6 +7772,50 @@
                     </a:solidFill>
                   </a:tcPr>
                 </a:tc>
+                <a:tc>
+                  <a:txBody>
+                    <a:bodyPr/>
+                    <a:lstStyle/>
+                    <a:p>
+                      <a:r>
+                        <a:rPr sz="1000">
+                          <a:solidFill>
+                            <a:srgbClr val="1A1A1A"/>
+                          </a:solidFill>
+                          <a:latin typeface="Calibri"/>
+                        </a:rPr>
+                        <a:t>pending</a:t>
+                      </a:r>
+                    </a:p>
+                  </a:txBody>
+                  <a:tcPr anchor="ctr">
+                    <a:solidFill>
+                      <a:srgbClr val="FFFFFF"/>
+                    </a:solidFill>
+                  </a:tcPr>
+                </a:tc>
+                <a:tc>
+                  <a:txBody>
+                    <a:bodyPr/>
+                    <a:lstStyle/>
+                    <a:p>
+                      <a:r>
+                        <a:rPr sz="1000">
+                          <a:solidFill>
+                            <a:srgbClr val="1A1A1A"/>
+                          </a:solidFill>
+                          <a:latin typeface="Calibri"/>
+                        </a:rPr>
+                        <a:t>pending</a:t>
+                      </a:r>
+                    </a:p>
+                  </a:txBody>
+                  <a:tcPr anchor="ctr">
+                    <a:solidFill>
+                      <a:srgbClr val="FFFFFF"/>
+                    </a:solidFill>
+                  </a:tcPr>
+                </a:tc>
               </a:tr>
             </a:tbl>
           </a:graphicData>
@@ -7574,14 +7823,53 @@
       </p:graphicFrame>
       <p:sp>
         <p:nvSpPr>
-          <p:cNvPr id="6" name="Rounded Rectangle 5"/>
+          <p:cNvPr id="6" name="TextBox 5"/>
+          <p:cNvSpPr txBox="1"/>
+          <p:nvPr/>
+        </p:nvSpPr>
+        <p:spPr>
+          <a:xfrm>
+            <a:off x="640080" y="3858768"/>
+            <a:ext cx="10908792" cy="274320"/>
+          </a:xfrm>
+          <a:prstGeom prst="rect">
+            <a:avLst/>
+          </a:prstGeom>
+          <a:noFill/>
+        </p:spPr>
+        <p:txBody>
+          <a:bodyPr wrap="square" lIns="0" rIns="0" tIns="0" bIns="0" anchor="t">
+            <a:spAutoFit/>
+          </a:bodyPr>
+          <a:lstStyle/>
+          <a:p>
+            <a:pPr algn="l">
+              <a:spcAft>
+                <a:spcPts val="600"/>
+              </a:spcAft>
+            </a:pPr>
+            <a:r>
+              <a:rPr sz="1100" b="0" i="1">
+                <a:solidFill>
+                  <a:srgbClr val="E8A33D"/>
+                </a:solidFill>
+                <a:latin typeface="Calibri"/>
+              </a:rPr>
+              <a:t>Right-hand columns reserved for closed frontier models — same prompts, same pipeline, see the next slide.</a:t>
+            </a:r>
+          </a:p>
+        </p:txBody>
+      </p:sp>
+      <p:sp>
+        <p:nvSpPr>
+          <p:cNvPr id="7" name="Rounded Rectangle 6"/>
           <p:cNvSpPr/>
           <p:nvPr/>
         </p:nvSpPr>
         <p:spPr>
           <a:xfrm>
-            <a:off x="640080" y="4069080"/>
-            <a:ext cx="10908792" cy="1051560"/>
+            <a:off x="640080" y="4224528"/>
+            <a:ext cx="10908792" cy="1005840"/>
           </a:xfrm>
           <a:prstGeom prst="roundRect">
             <a:avLst>
@@ -7620,14 +7908,14 @@
       </p:sp>
       <p:sp>
         <p:nvSpPr>
-          <p:cNvPr id="7" name="TextBox 6"/>
+          <p:cNvPr id="8" name="TextBox 7"/>
           <p:cNvSpPr txBox="1"/>
           <p:nvPr/>
         </p:nvSpPr>
         <p:spPr>
           <a:xfrm>
-            <a:off x="914400" y="4224528"/>
-            <a:ext cx="10332720" cy="822960"/>
+            <a:off x="914400" y="4370832"/>
+            <a:ext cx="10332720" cy="777240"/>
           </a:xfrm>
           <a:prstGeom prst="rect">
             <a:avLst/>
@@ -7659,14 +7947,14 @@
       </p:sp>
       <p:sp>
         <p:nvSpPr>
-          <p:cNvPr id="8" name="TextBox 7"/>
+          <p:cNvPr id="9" name="TextBox 8"/>
           <p:cNvSpPr txBox="1"/>
           <p:nvPr/>
         </p:nvSpPr>
         <p:spPr>
           <a:xfrm>
-            <a:off x="640080" y="5349240"/>
-            <a:ext cx="10908792" cy="1188720"/>
+            <a:off x="640080" y="5440680"/>
+            <a:ext cx="10908792" cy="1097280"/>
           </a:xfrm>
           <a:prstGeom prst="rect">
             <a:avLst/>
@@ -8729,7 +9017,7 @@
                 </a:solidFill>
                 <a:latin typeface="Cambria"/>
               </a:rPr>
-              <a:t>Demonstration</a:t>
+              <a:t>Results 6: Frontier Models</a:t>
             </a:r>
           </a:p>
         </p:txBody>
@@ -8768,7 +9056,7 @@
                 </a:solidFill>
                 <a:latin typeface="Calibri"/>
               </a:rPr>
-              <a:t>Live: one image in, a diagnosed failure out</a:t>
+              <a:t>Reserved — the direct test of “has the geometric tell disappeared?”</a:t>
             </a:r>
           </a:p>
         </p:txBody>
@@ -8782,7 +9070,7 @@
         <p:spPr>
           <a:xfrm>
             <a:off x="640080" y="1828800"/>
-            <a:ext cx="5394960" cy="3931920"/>
+            <a:ext cx="5394960" cy="3749039"/>
           </a:xfrm>
           <a:prstGeom prst="roundRect">
             <a:avLst>
@@ -8828,7 +9116,7 @@
         <p:spPr>
           <a:xfrm>
             <a:off x="914400" y="2057400"/>
-            <a:ext cx="4846320" cy="411480"/>
+            <a:ext cx="4846320" cy="365760"/>
           </a:xfrm>
           <a:prstGeom prst="rect">
             <a:avLst/>
@@ -8853,7 +9141,7 @@
                 </a:solidFill>
                 <a:latin typeface="Calibri"/>
               </a:rPr>
-              <a:t>COMMAND</a:t>
+              <a:t>WHY THIS SLOT EXISTS</a:t>
             </a:r>
           </a:p>
         </p:txBody>
@@ -8867,7 +9155,7 @@
         <p:spPr>
           <a:xfrm>
             <a:off x="914400" y="2514600"/>
-            <a:ext cx="4846320" cy="457200"/>
+            <a:ext cx="4846320" cy="2834640"/>
           </a:xfrm>
           <a:prstGeom prst="rect">
             <a:avLst/>
@@ -8882,31 +9170,141 @@
           <a:p>
             <a:pPr algn="l">
               <a:spcAft>
-                <a:spcPts val="600"/>
-              </a:spcAft>
-            </a:pPr>
-            <a:r>
-              <a:rPr sz="1250" b="0" i="0">
-                <a:solidFill>
-                  <a:srgbClr val="1C7293"/>
-                </a:solidFill>
-                <a:latin typeface="Courier New"/>
-              </a:rPr>
-              <a:t>python scripts/analyze_image.py &lt;image&gt; --out outputs/</a:t>
-            </a:r>
-          </a:p>
-        </p:txBody>
-      </p:sp>
-      <p:sp>
-        <p:nvSpPr>
-          <p:cNvPr id="8" name="TextBox 7"/>
+                <a:spcPts val="400"/>
+              </a:spcAft>
+            </a:pPr>
+            <a:r>
+              <a:rPr sz="1300" b="0" i="0">
+                <a:solidFill>
+                  <a:srgbClr val="1A1A1A"/>
+                </a:solidFill>
+                <a:latin typeface="Calibri"/>
+              </a:rPr>
+              <a:t>SD 1.5 and SDXL are separated by about two years of model development. Across that gap orientation improves and camera coherence does not.</a:t>
+            </a:r>
+          </a:p>
+          <a:p>
+            <a:pPr algn="l">
+              <a:spcAft>
+                <a:spcPts val="400"/>
+              </a:spcAft>
+            </a:pPr>
+            <a:r>
+              <a:rPr sz="1300" b="0" i="0">
+                <a:solidFill>
+                  <a:srgbClr val="1A1A1A"/>
+                </a:solidFill>
+                <a:latin typeface="Calibri"/>
+              </a:rPr>
+              <a:t/>
+            </a:r>
+          </a:p>
+          <a:p>
+            <a:pPr algn="l">
+              <a:spcAft>
+                <a:spcPts val="400"/>
+              </a:spcAft>
+            </a:pPr>
+            <a:r>
+              <a:rPr sz="1300" b="0" i="0">
+                <a:solidFill>
+                  <a:srgbClr val="1A1A1A"/>
+                </a:solidFill>
+                <a:latin typeface="Calibri"/>
+              </a:rPr>
+              <a:t>A current frontier model is therefore the decisive test of the 2026 claim that the geometric tell is gone.</a:t>
+            </a:r>
+          </a:p>
+          <a:p>
+            <a:pPr algn="l">
+              <a:spcAft>
+                <a:spcPts val="400"/>
+              </a:spcAft>
+            </a:pPr>
+            <a:r>
+              <a:rPr sz="1300" b="0" i="0">
+                <a:solidFill>
+                  <a:srgbClr val="1A1A1A"/>
+                </a:solidFill>
+                <a:latin typeface="Calibri"/>
+              </a:rPr>
+              <a:t/>
+            </a:r>
+          </a:p>
+          <a:p>
+            <a:pPr algn="l">
+              <a:spcAft>
+                <a:spcPts val="400"/>
+              </a:spcAft>
+            </a:pPr>
+            <a:r>
+              <a:rPr sz="1300" b="0" i="0">
+                <a:solidFill>
+                  <a:srgbClr val="1A1A1A"/>
+                </a:solidFill>
+                <a:latin typeface="Calibri"/>
+              </a:rPr>
+              <a:t>The pipeline is model-agnostic: no code changes are needed to accept these images.</a:t>
+            </a:r>
+          </a:p>
+        </p:txBody>
+      </p:sp>
+      <p:sp>
+        <p:nvSpPr>
+          <p:cNvPr id="8" name="Rounded Rectangle 7"/>
+          <p:cNvSpPr/>
+          <p:nvPr/>
+        </p:nvSpPr>
+        <p:spPr>
+          <a:xfrm>
+            <a:off x="6245352" y="1828800"/>
+            <a:ext cx="5303520" cy="3749039"/>
+          </a:xfrm>
+          <a:prstGeom prst="roundRect">
+            <a:avLst>
+              <a:gd name="adj" fmla="val 6000"/>
+            </a:avLst>
+          </a:prstGeom>
+          <a:solidFill>
+            <a:srgbClr val="12263A"/>
+          </a:solidFill>
+          <a:ln>
+            <a:noFill/>
+          </a:ln>
+          <a:effectLst/>
+        </p:spPr>
+        <p:style>
+          <a:lnRef idx="1">
+            <a:schemeClr val="accent1"/>
+          </a:lnRef>
+          <a:fillRef idx="3">
+            <a:schemeClr val="accent1"/>
+          </a:fillRef>
+          <a:effectRef idx="2">
+            <a:schemeClr val="accent1"/>
+          </a:effectRef>
+          <a:fontRef idx="minor">
+            <a:schemeClr val="lt1"/>
+          </a:fontRef>
+        </p:style>
+        <p:txBody>
+          <a:bodyPr rtlCol="0" anchor="ctr"/>
+          <a:lstStyle/>
+          <a:p>
+            <a:pPr algn="ctr"/>
+          </a:p>
+        </p:txBody>
+      </p:sp>
+      <p:sp>
+        <p:nvSpPr>
+          <p:cNvPr id="9" name="TextBox 8"/>
           <p:cNvSpPr txBox="1"/>
           <p:nvPr/>
         </p:nvSpPr>
         <p:spPr>
           <a:xfrm>
-            <a:off x="914400" y="3108960"/>
-            <a:ext cx="4846320" cy="411480"/>
+            <a:off x="6519672" y="2057400"/>
+            <a:ext cx="4754880" cy="365760"/>
           </a:xfrm>
           <a:prstGeom prst="rect">
             <a:avLst/>
@@ -8927,25 +9325,25 @@
             <a:r>
               <a:rPr sz="1200" b="1" i="0">
                 <a:solidFill>
-                  <a:srgbClr val="12263A"/>
+                  <a:srgbClr val="E8A33D"/>
                 </a:solidFill>
                 <a:latin typeface="Calibri"/>
               </a:rPr>
-              <a:t>OUTPUT</a:t>
-            </a:r>
-          </a:p>
-        </p:txBody>
-      </p:sp>
-      <p:sp>
-        <p:nvSpPr>
-          <p:cNvPr id="9" name="TextBox 8"/>
+              <a:t>PROCEDURE</a:t>
+            </a:r>
+          </a:p>
+        </p:txBody>
+      </p:sp>
+      <p:sp>
+        <p:nvSpPr>
+          <p:cNvPr id="10" name="TextBox 9"/>
           <p:cNvSpPr txBox="1"/>
           <p:nvPr/>
         </p:nvSpPr>
         <p:spPr>
           <a:xfrm>
-            <a:off x="914400" y="3520440"/>
-            <a:ext cx="4846320" cy="2011680"/>
+            <a:off x="6519672" y="2514600"/>
+            <a:ext cx="4754880" cy="2926080"/>
           </a:xfrm>
           <a:prstGeom prst="rect">
             <a:avLst/>
@@ -8960,63 +9358,95 @@
           <a:p>
             <a:pPr>
               <a:spcAft>
-                <a:spcPts val="700"/>
-              </a:spcAft>
-            </a:pPr>
-            <a:r>
-              <a:rPr sz="1250" b="0">
-                <a:solidFill>
-                  <a:srgbClr val="1A1A1A"/>
+                <a:spcPts val="600"/>
+              </a:spcAft>
+            </a:pPr>
+            <a:r>
+              <a:rPr sz="1200" b="0">
+                <a:solidFill>
+                  <a:srgbClr val="FFFFFF"/>
                 </a:solidFill>
                 <a:latin typeface="Calibri"/>
               </a:rPr>
-              <a:t>•  Overlay: segments coloured by VP cluster</a:t>
+              <a:t>•  Same 200 prompts, already exported to data/generated/prompts.txt</a:t>
             </a:r>
           </a:p>
           <a:p>
             <a:pPr>
               <a:spcAft>
-                <a:spcPts val="700"/>
-              </a:spcAft>
-            </a:pPr>
-            <a:r>
-              <a:rPr sz="1250" b="0">
-                <a:solidFill>
-                  <a:srgbClr val="1A1A1A"/>
+                <a:spcPts val="600"/>
+              </a:spcAft>
+            </a:pPr>
+            <a:r>
+              <a:rPr sz="1200" b="0">
+                <a:solidFill>
+                  <a:srgbClr val="FFFFFF"/>
                 </a:solidFill>
                 <a:latin typeface="Calibri"/>
               </a:rPr>
-              <a:t>•  Vanishing points and the orthocentre vs image centre</a:t>
+              <a:t>•  Save as 0000.png, 0001.png … keeping the prompt index, into data/generated/gemini/ and data/generated/gptimage/</a:t>
             </a:r>
           </a:p>
           <a:p>
             <a:pPr>
               <a:spcAft>
-                <a:spcPts val="700"/>
-              </a:spcAft>
-            </a:pPr>
-            <a:r>
-              <a:rPr sz="1250" b="0">
-                <a:solidFill>
-                  <a:srgbClr val="1A1A1A"/>
+                <a:spcPts val="600"/>
+              </a:spcAft>
+            </a:pPr>
+            <a:r>
+              <a:rPr sz="1200" b="0">
+                <a:solidFill>
+                  <a:srgbClr val="FFFFFF"/>
                 </a:solidFill>
                 <a:latin typeface="Calibri"/>
               </a:rPr>
-              <a:t>•  JSON of every residual, and a CSV summary row</a:t>
-            </a:r>
-          </a:p>
-        </p:txBody>
-      </p:sp>
-      <p:sp>
-        <p:nvSpPr>
-          <p:cNvPr id="10" name="Rounded Rectangle 9"/>
+              <a:t>•  Record model version and date in a README.txt per folder</a:t>
+            </a:r>
+          </a:p>
+          <a:p>
+            <a:pPr>
+              <a:spcAft>
+                <a:spcPts val="600"/>
+              </a:spcAft>
+            </a:pPr>
+            <a:r>
+              <a:rPr sz="1200" b="0">
+                <a:solidFill>
+                  <a:srgbClr val="FFFFFF"/>
+                </a:solidFill>
+                <a:latin typeface="Calibri"/>
+              </a:rPr>
+              <a:t>•  Run scripts/atlanta_compare.py with the new folders appended to --gen</a:t>
+            </a:r>
+          </a:p>
+          <a:p>
+            <a:pPr>
+              <a:spcAft>
+                <a:spcPts val="600"/>
+              </a:spcAft>
+            </a:pPr>
+            <a:r>
+              <a:rPr sz="1200" b="0">
+                <a:solidFill>
+                  <a:srgbClr val="FFFFFF"/>
+                </a:solidFill>
+                <a:latin typeface="Calibri"/>
+              </a:rPr>
+              <a:t>•  30–50 images per model is enough for the median and its interval</a:t>
+            </a:r>
+          </a:p>
+        </p:txBody>
+      </p:sp>
+      <p:sp>
+        <p:nvSpPr>
+          <p:cNvPr id="11" name="Rounded Rectangle 10"/>
           <p:cNvSpPr/>
           <p:nvPr/>
         </p:nvSpPr>
         <p:spPr>
           <a:xfrm>
-            <a:off x="6309360" y="1828800"/>
-            <a:ext cx="5239512" cy="1828800"/>
+            <a:off x="640080" y="5715000"/>
+            <a:ext cx="10908792" cy="914400"/>
           </a:xfrm>
           <a:prstGeom prst="roundRect">
             <a:avLst>
@@ -9057,14 +9487,14 @@
       </p:sp>
       <p:sp>
         <p:nvSpPr>
-          <p:cNvPr id="11" name="TextBox 10"/>
+          <p:cNvPr id="12" name="TextBox 11"/>
           <p:cNvSpPr txBox="1"/>
           <p:nvPr/>
         </p:nvSpPr>
         <p:spPr>
           <a:xfrm>
-            <a:off x="6537960" y="2029968"/>
-            <a:ext cx="4782312" cy="1426464"/>
+            <a:off x="868680" y="5916168"/>
+            <a:ext cx="10451592" cy="512064"/>
           </a:xfrm>
           <a:prstGeom prst="rect">
             <a:avLst/>
@@ -9089,70 +9519,7 @@
                 </a:solidFill>
                 <a:latin typeface="Calibri"/>
               </a:rPr>
-              <a:t>[TO ADD] Screenshot of the terminal running analyze_image.py on one generated image, showing the printed residuals.</a:t>
-            </a:r>
-          </a:p>
-        </p:txBody>
-      </p:sp>
-      <p:pic>
-        <p:nvPicPr>
-          <p:cNvPr id="12" name="Picture 11" descr="example_sdxl_0010_three_cameras.png"/>
-          <p:cNvPicPr>
-            <a:picLocks noChangeAspect="1"/>
-          </p:cNvPicPr>
-          <p:nvPr/>
-        </p:nvPicPr>
-        <p:blipFill>
-          <a:blip r:embed="rId2"/>
-          <a:stretch>
-            <a:fillRect/>
-          </a:stretch>
-        </p:blipFill>
-        <p:spPr>
-          <a:xfrm>
-            <a:off x="7360920" y="3840480"/>
-            <a:ext cx="2326005" cy="1691640"/>
-          </a:xfrm>
-          <a:prstGeom prst="rect">
-            <a:avLst/>
-          </a:prstGeom>
-        </p:spPr>
-      </p:pic>
-      <p:sp>
-        <p:nvSpPr>
-          <p:cNvPr id="13" name="TextBox 12"/>
-          <p:cNvSpPr txBox="1"/>
-          <p:nvPr/>
-        </p:nvSpPr>
-        <p:spPr>
-          <a:xfrm>
-            <a:off x="6309360" y="5669280"/>
-            <a:ext cx="5239512" cy="640080"/>
-          </a:xfrm>
-          <a:prstGeom prst="rect">
-            <a:avLst/>
-          </a:prstGeom>
-          <a:noFill/>
-        </p:spPr>
-        <p:txBody>
-          <a:bodyPr wrap="square" lIns="0" rIns="0" tIns="0" bIns="0" anchor="t">
-            <a:spAutoFit/>
-          </a:bodyPr>
-          <a:lstStyle/>
-          <a:p>
-            <a:pPr algn="l">
-              <a:spcAft>
-                <a:spcPts val="600"/>
-              </a:spcAft>
-            </a:pPr>
-            <a:r>
-              <a:rPr sz="1150" b="0" i="1">
-                <a:solidFill>
-                  <a:srgbClr val="5A6672"/>
-                </a:solidFill>
-                <a:latin typeface="Calibri"/>
-              </a:rPr>
-              <a:t>A generated street scene whose three VP pairs imply focal lengths of 1626, 321 and 951 px — three different cameras in one image.</a:t>
+              <a:t>[TO ADD] Once the images exist, paste the two new columns into the Results 3 table and replace this slide with the comparison figure produced by atlanta_compare.py.</a:t>
             </a:r>
           </a:p>
         </p:txBody>
@@ -9190,7 +9557,7 @@
             <a:avLst/>
           </a:prstGeom>
           <a:solidFill>
-            <a:srgbClr val="12263A"/>
+            <a:srgbClr val="FFFFFF"/>
           </a:solidFill>
           <a:ln>
             <a:noFill/>
@@ -9249,31 +9616,72 @@
             <a:r>
               <a:rPr sz="3200" b="1" i="0">
                 <a:solidFill>
-                  <a:srgbClr val="FFFFFF"/>
+                  <a:srgbClr val="12263A"/>
                 </a:solidFill>
                 <a:latin typeface="Cambria"/>
               </a:rPr>
-              <a:t>Conclusion</a:t>
-            </a:r>
-          </a:p>
-        </p:txBody>
-      </p:sp>
-      <p:sp>
-        <p:nvSpPr>
-          <p:cNvPr id="4" name="Oval 3"/>
+              <a:t>Demonstration</a:t>
+            </a:r>
+          </a:p>
+        </p:txBody>
+      </p:sp>
+      <p:sp>
+        <p:nvSpPr>
+          <p:cNvPr id="4" name="TextBox 3"/>
+          <p:cNvSpPr txBox="1"/>
+          <p:nvPr/>
+        </p:nvSpPr>
+        <p:spPr>
+          <a:xfrm>
+            <a:off x="640080" y="1207008"/>
+            <a:ext cx="10911535" cy="411480"/>
+          </a:xfrm>
+          <a:prstGeom prst="rect">
+            <a:avLst/>
+          </a:prstGeom>
+          <a:noFill/>
+        </p:spPr>
+        <p:txBody>
+          <a:bodyPr wrap="square" lIns="0" rIns="0" tIns="0" bIns="0" anchor="t">
+            <a:spAutoFit/>
+          </a:bodyPr>
+          <a:lstStyle/>
+          <a:p>
+            <a:pPr algn="l">
+              <a:spcAft>
+                <a:spcPts val="600"/>
+              </a:spcAft>
+            </a:pPr>
+            <a:r>
+              <a:rPr sz="1400" b="0" i="1">
+                <a:solidFill>
+                  <a:srgbClr val="5A6672"/>
+                </a:solidFill>
+                <a:latin typeface="Calibri"/>
+              </a:rPr>
+              <a:t>Live: one image in, a diagnosed failure out</a:t>
+            </a:r>
+          </a:p>
+        </p:txBody>
+      </p:sp>
+      <p:sp>
+        <p:nvSpPr>
+          <p:cNvPr id="5" name="Rounded Rectangle 4"/>
           <p:cNvSpPr/>
           <p:nvPr/>
         </p:nvSpPr>
         <p:spPr>
           <a:xfrm>
-            <a:off x="685800" y="1984248"/>
-            <a:ext cx="274320" cy="274320"/>
-          </a:xfrm>
-          <a:prstGeom prst="ellipse">
-            <a:avLst/>
+            <a:off x="640080" y="1828800"/>
+            <a:ext cx="5394960" cy="3931920"/>
+          </a:xfrm>
+          <a:prstGeom prst="roundRect">
+            <a:avLst>
+              <a:gd name="adj" fmla="val 6000"/>
+            </a:avLst>
           </a:prstGeom>
           <a:solidFill>
-            <a:srgbClr val="E8A33D"/>
+            <a:srgbClr val="F4F6F8"/>
           </a:solidFill>
           <a:ln>
             <a:noFill/>
@@ -9304,14 +9712,14 @@
       </p:sp>
       <p:sp>
         <p:nvSpPr>
-          <p:cNvPr id="5" name="TextBox 4"/>
+          <p:cNvPr id="6" name="TextBox 5"/>
           <p:cNvSpPr txBox="1"/>
           <p:nvPr/>
         </p:nvSpPr>
         <p:spPr>
           <a:xfrm>
-            <a:off x="1188720" y="1874519"/>
-            <a:ext cx="10332720" cy="411480"/>
+            <a:off x="914400" y="2057400"/>
+            <a:ext cx="4846320" cy="411480"/>
           </a:xfrm>
           <a:prstGeom prst="rect">
             <a:avLst/>
@@ -9330,27 +9738,27 @@
               </a:spcAft>
             </a:pPr>
             <a:r>
-              <a:rPr sz="1700" b="1" i="0">
-                <a:solidFill>
-                  <a:srgbClr val="FFFFFF"/>
-                </a:solidFill>
-                <a:latin typeface="Cambria"/>
-              </a:rPr>
-              <a:t>Generators reproduce orientation, not the camera</a:t>
-            </a:r>
-          </a:p>
-        </p:txBody>
-      </p:sp>
-      <p:sp>
-        <p:nvSpPr>
-          <p:cNvPr id="6" name="TextBox 5"/>
+              <a:rPr sz="1200" b="1" i="0">
+                <a:solidFill>
+                  <a:srgbClr val="12263A"/>
+                </a:solidFill>
+                <a:latin typeface="Calibri"/>
+              </a:rPr>
+              <a:t>COMMAND</a:t>
+            </a:r>
+          </a:p>
+        </p:txBody>
+      </p:sp>
+      <p:sp>
+        <p:nvSpPr>
+          <p:cNvPr id="7" name="TextBox 6"/>
           <p:cNvSpPr txBox="1"/>
           <p:nvPr/>
         </p:nvSpPr>
         <p:spPr>
           <a:xfrm>
-            <a:off x="1188720" y="2331720"/>
-            <a:ext cx="10332720" cy="594360"/>
+            <a:off x="914400" y="2514600"/>
+            <a:ext cx="4846320" cy="457200"/>
           </a:xfrm>
           <a:prstGeom prst="rect">
             <a:avLst/>
@@ -9369,36 +9777,150 @@
               </a:spcAft>
             </a:pPr>
             <a:r>
-              <a:rPr sz="1300" b="0" i="0">
-                <a:solidFill>
-                  <a:srgbClr val="B9CDDA"/>
+              <a:rPr sz="1250" b="0" i="0">
+                <a:solidFill>
+                  <a:srgbClr val="1C7293"/>
+                </a:solidFill>
+                <a:latin typeface="Courier New"/>
+              </a:rPr>
+              <a:t>python scripts/analyze_image.py &lt;image&gt; --out outputs/</a:t>
+            </a:r>
+          </a:p>
+        </p:txBody>
+      </p:sp>
+      <p:sp>
+        <p:nvSpPr>
+          <p:cNvPr id="8" name="TextBox 7"/>
+          <p:cNvSpPr txBox="1"/>
+          <p:nvPr/>
+        </p:nvSpPr>
+        <p:spPr>
+          <a:xfrm>
+            <a:off x="914400" y="3108960"/>
+            <a:ext cx="4846320" cy="411480"/>
+          </a:xfrm>
+          <a:prstGeom prst="rect">
+            <a:avLst/>
+          </a:prstGeom>
+          <a:noFill/>
+        </p:spPr>
+        <p:txBody>
+          <a:bodyPr wrap="square" lIns="0" rIns="0" tIns="0" bIns="0" anchor="t">
+            <a:spAutoFit/>
+          </a:bodyPr>
+          <a:lstStyle/>
+          <a:p>
+            <a:pPr algn="l">
+              <a:spcAft>
+                <a:spcPts val="600"/>
+              </a:spcAft>
+            </a:pPr>
+            <a:r>
+              <a:rPr sz="1200" b="1" i="0">
+                <a:solidFill>
+                  <a:srgbClr val="12263A"/>
                 </a:solidFill>
                 <a:latin typeface="Calibri"/>
               </a:rPr>
-              <a:t>Manhattan orthogonality is comparable to real photographs after control; focal and principal-point coherence is 2.5-3× worse.</a:t>
-            </a:r>
-          </a:p>
-        </p:txBody>
-      </p:sp>
-      <p:sp>
-        <p:nvSpPr>
-          <p:cNvPr id="7" name="Oval 6"/>
+              <a:t>OUTPUT</a:t>
+            </a:r>
+          </a:p>
+        </p:txBody>
+      </p:sp>
+      <p:sp>
+        <p:nvSpPr>
+          <p:cNvPr id="9" name="TextBox 8"/>
+          <p:cNvSpPr txBox="1"/>
+          <p:nvPr/>
+        </p:nvSpPr>
+        <p:spPr>
+          <a:xfrm>
+            <a:off x="914400" y="3520440"/>
+            <a:ext cx="4846320" cy="2011680"/>
+          </a:xfrm>
+          <a:prstGeom prst="rect">
+            <a:avLst/>
+          </a:prstGeom>
+          <a:noFill/>
+        </p:spPr>
+        <p:txBody>
+          <a:bodyPr wrap="square" lIns="0" rIns="0" tIns="0" bIns="0">
+            <a:spAutoFit/>
+          </a:bodyPr>
+          <a:lstStyle/>
+          <a:p>
+            <a:pPr>
+              <a:spcAft>
+                <a:spcPts val="700"/>
+              </a:spcAft>
+            </a:pPr>
+            <a:r>
+              <a:rPr sz="1250" b="0">
+                <a:solidFill>
+                  <a:srgbClr val="1A1A1A"/>
+                </a:solidFill>
+                <a:latin typeface="Calibri"/>
+              </a:rPr>
+              <a:t>•  Overlay: segments coloured by VP cluster</a:t>
+            </a:r>
+          </a:p>
+          <a:p>
+            <a:pPr>
+              <a:spcAft>
+                <a:spcPts val="700"/>
+              </a:spcAft>
+            </a:pPr>
+            <a:r>
+              <a:rPr sz="1250" b="0">
+                <a:solidFill>
+                  <a:srgbClr val="1A1A1A"/>
+                </a:solidFill>
+                <a:latin typeface="Calibri"/>
+              </a:rPr>
+              <a:t>•  Vanishing points and the orthocentre vs image centre</a:t>
+            </a:r>
+          </a:p>
+          <a:p>
+            <a:pPr>
+              <a:spcAft>
+                <a:spcPts val="700"/>
+              </a:spcAft>
+            </a:pPr>
+            <a:r>
+              <a:rPr sz="1250" b="0">
+                <a:solidFill>
+                  <a:srgbClr val="1A1A1A"/>
+                </a:solidFill>
+                <a:latin typeface="Calibri"/>
+              </a:rPr>
+              <a:t>•  JSON of every residual, and a CSV summary row</a:t>
+            </a:r>
+          </a:p>
+        </p:txBody>
+      </p:sp>
+      <p:sp>
+        <p:nvSpPr>
+          <p:cNvPr id="10" name="Rounded Rectangle 9"/>
           <p:cNvSpPr/>
           <p:nvPr/>
         </p:nvSpPr>
         <p:spPr>
           <a:xfrm>
-            <a:off x="685800" y="3099815"/>
-            <a:ext cx="274320" cy="274320"/>
-          </a:xfrm>
-          <a:prstGeom prst="ellipse">
-            <a:avLst/>
+            <a:off x="6309360" y="1828800"/>
+            <a:ext cx="5239512" cy="1828800"/>
+          </a:xfrm>
+          <a:prstGeom prst="roundRect">
+            <a:avLst>
+              <a:gd name="adj" fmla="val 6000"/>
+            </a:avLst>
           </a:prstGeom>
           <a:solidFill>
-            <a:srgbClr val="E8A33D"/>
+            <a:srgbClr val="FDF3E2"/>
           </a:solidFill>
-          <a:ln>
-            <a:noFill/>
+          <a:ln w="15875">
+            <a:solidFill>
+              <a:srgbClr val="E8A33D"/>
+            </a:solidFill>
           </a:ln>
           <a:effectLst/>
         </p:spPr>
@@ -9426,14 +9948,14 @@
       </p:sp>
       <p:sp>
         <p:nvSpPr>
-          <p:cNvPr id="8" name="TextBox 7"/>
+          <p:cNvPr id="11" name="TextBox 10"/>
           <p:cNvSpPr txBox="1"/>
           <p:nvPr/>
         </p:nvSpPr>
         <p:spPr>
           <a:xfrm>
-            <a:off x="1188720" y="2990087"/>
-            <a:ext cx="10332720" cy="411480"/>
+            <a:off x="6537960" y="2029968"/>
+            <a:ext cx="4782312" cy="1426464"/>
           </a:xfrm>
           <a:prstGeom prst="rect">
             <a:avLst/>
@@ -9452,27 +9974,51 @@
               </a:spcAft>
             </a:pPr>
             <a:r>
-              <a:rPr sz="1700" b="1" i="0">
-                <a:solidFill>
-                  <a:srgbClr val="FFFFFF"/>
-                </a:solidFill>
-                <a:latin typeface="Cambria"/>
-              </a:rPr>
-              <a:t>The result is robust to the real reference</a:t>
-            </a:r>
-          </a:p>
-        </p:txBody>
-      </p:sp>
-      <p:sp>
-        <p:nvSpPr>
-          <p:cNvPr id="9" name="TextBox 8"/>
+              <a:rPr sz="1200" b="0" i="1">
+                <a:solidFill>
+                  <a:srgbClr val="8A5A12"/>
+                </a:solidFill>
+                <a:latin typeface="Calibri"/>
+              </a:rPr>
+              <a:t>[TO ADD] Screenshot of the terminal running analyze_image.py on one generated image, showing the printed residuals.</a:t>
+            </a:r>
+          </a:p>
+        </p:txBody>
+      </p:sp>
+      <p:pic>
+        <p:nvPicPr>
+          <p:cNvPr id="12" name="Picture 11" descr="example_sdxl_0010_three_cameras.png"/>
+          <p:cNvPicPr>
+            <a:picLocks noChangeAspect="1"/>
+          </p:cNvPicPr>
+          <p:nvPr/>
+        </p:nvPicPr>
+        <p:blipFill>
+          <a:blip r:embed="rId2"/>
+          <a:stretch>
+            <a:fillRect/>
+          </a:stretch>
+        </p:blipFill>
+        <p:spPr>
+          <a:xfrm>
+            <a:off x="7360920" y="3840480"/>
+            <a:ext cx="2326005" cy="1691640"/>
+          </a:xfrm>
+          <a:prstGeom prst="rect">
+            <a:avLst/>
+          </a:prstGeom>
+        </p:spPr>
+      </p:pic>
+      <p:sp>
+        <p:nvSpPr>
+          <p:cNvPr id="13" name="TextBox 12"/>
           <p:cNvSpPr txBox="1"/>
           <p:nvPr/>
         </p:nvSpPr>
         <p:spPr>
           <a:xfrm>
-            <a:off x="1188720" y="3447287"/>
-            <a:ext cx="10332720" cy="594360"/>
+            <a:off x="6309360" y="5669280"/>
+            <a:ext cx="5239512" cy="640080"/>
           </a:xfrm>
           <a:prstGeom prst="rect">
             <a:avLst/>
@@ -9491,296 +10037,13 @@
               </a:spcAft>
             </a:pPr>
             <a:r>
-              <a:rPr sz="1300" b="0" i="0">
-                <a:solidFill>
-                  <a:srgbClr val="B9CDDA"/>
+              <a:rPr sz="1150" b="0" i="1">
+                <a:solidFill>
+                  <a:srgbClr val="5A6672"/>
                 </a:solidFill>
                 <a:latin typeface="Calibri"/>
               </a:rPr>
-              <a:t>Both a curated benchmark and uncurated internet photographs give the same conclusion, with non-overlapping confidence intervals.</a:t>
-            </a:r>
-          </a:p>
-        </p:txBody>
-      </p:sp>
-      <p:sp>
-        <p:nvSpPr>
-          <p:cNvPr id="10" name="Oval 9"/>
-          <p:cNvSpPr/>
-          <p:nvPr/>
-        </p:nvSpPr>
-        <p:spPr>
-          <a:xfrm>
-            <a:off x="685800" y="4215384"/>
-            <a:ext cx="274320" cy="274320"/>
-          </a:xfrm>
-          <a:prstGeom prst="ellipse">
-            <a:avLst/>
-          </a:prstGeom>
-          <a:solidFill>
-            <a:srgbClr val="E8A33D"/>
-          </a:solidFill>
-          <a:ln>
-            <a:noFill/>
-          </a:ln>
-          <a:effectLst/>
-        </p:spPr>
-        <p:style>
-          <a:lnRef idx="1">
-            <a:schemeClr val="accent1"/>
-          </a:lnRef>
-          <a:fillRef idx="3">
-            <a:schemeClr val="accent1"/>
-          </a:fillRef>
-          <a:effectRef idx="2">
-            <a:schemeClr val="accent1"/>
-          </a:effectRef>
-          <a:fontRef idx="minor">
-            <a:schemeClr val="lt1"/>
-          </a:fontRef>
-        </p:style>
-        <p:txBody>
-          <a:bodyPr rtlCol="0" anchor="ctr"/>
-          <a:lstStyle/>
-          <a:p>
-            <a:pPr algn="ctr"/>
-          </a:p>
-        </p:txBody>
-      </p:sp>
-      <p:sp>
-        <p:nvSpPr>
-          <p:cNvPr id="11" name="TextBox 10"/>
-          <p:cNvSpPr txBox="1"/>
-          <p:nvPr/>
-        </p:nvSpPr>
-        <p:spPr>
-          <a:xfrm>
-            <a:off x="1188720" y="4105656"/>
-            <a:ext cx="10332720" cy="411480"/>
-          </a:xfrm>
-          <a:prstGeom prst="rect">
-            <a:avLst/>
-          </a:prstGeom>
-          <a:noFill/>
-        </p:spPr>
-        <p:txBody>
-          <a:bodyPr wrap="square" lIns="0" rIns="0" tIns="0" bIns="0" anchor="t">
-            <a:spAutoFit/>
-          </a:bodyPr>
-          <a:lstStyle/>
-          <a:p>
-            <a:pPr algn="l">
-              <a:spcAft>
-                <a:spcPts val="600"/>
-              </a:spcAft>
-            </a:pPr>
-            <a:r>
-              <a:rPr sz="1700" b="1" i="0">
-                <a:solidFill>
-                  <a:srgbClr val="FFFFFF"/>
-                </a:solidFill>
-                <a:latin typeface="Cambria"/>
-              </a:rPr>
-              <a:t>Scale is not closing the gap</a:t>
-            </a:r>
-          </a:p>
-        </p:txBody>
-      </p:sp>
-      <p:sp>
-        <p:nvSpPr>
-          <p:cNvPr id="12" name="TextBox 11"/>
-          <p:cNvSpPr txBox="1"/>
-          <p:nvPr/>
-        </p:nvSpPr>
-        <p:spPr>
-          <a:xfrm>
-            <a:off x="1188720" y="4562856"/>
-            <a:ext cx="10332720" cy="594360"/>
-          </a:xfrm>
-          <a:prstGeom prst="rect">
-            <a:avLst/>
-          </a:prstGeom>
-          <a:noFill/>
-        </p:spPr>
-        <p:txBody>
-          <a:bodyPr wrap="square" lIns="0" rIns="0" tIns="0" bIns="0" anchor="t">
-            <a:spAutoFit/>
-          </a:bodyPr>
-          <a:lstStyle/>
-          <a:p>
-            <a:pPr algn="l">
-              <a:spcAft>
-                <a:spcPts val="600"/>
-              </a:spcAft>
-            </a:pPr>
-            <a:r>
-              <a:rPr sz="1300" b="0" i="0">
-                <a:solidFill>
-                  <a:srgbClr val="B9CDDA"/>
-                </a:solidFill>
-                <a:latin typeface="Calibri"/>
-              </a:rPr>
-              <a:t>SD 1.5 → SDXL improves orientation significantly and leaves camera coherence unchanged.</a:t>
-            </a:r>
-          </a:p>
-        </p:txBody>
-      </p:sp>
-      <p:sp>
-        <p:nvSpPr>
-          <p:cNvPr id="13" name="Oval 12"/>
-          <p:cNvSpPr/>
-          <p:nvPr/>
-        </p:nvSpPr>
-        <p:spPr>
-          <a:xfrm>
-            <a:off x="685800" y="5330952"/>
-            <a:ext cx="274320" cy="274320"/>
-          </a:xfrm>
-          <a:prstGeom prst="ellipse">
-            <a:avLst/>
-          </a:prstGeom>
-          <a:solidFill>
-            <a:srgbClr val="E8A33D"/>
-          </a:solidFill>
-          <a:ln>
-            <a:noFill/>
-          </a:ln>
-          <a:effectLst/>
-        </p:spPr>
-        <p:style>
-          <a:lnRef idx="1">
-            <a:schemeClr val="accent1"/>
-          </a:lnRef>
-          <a:fillRef idx="3">
-            <a:schemeClr val="accent1"/>
-          </a:fillRef>
-          <a:effectRef idx="2">
-            <a:schemeClr val="accent1"/>
-          </a:effectRef>
-          <a:fontRef idx="minor">
-            <a:schemeClr val="lt1"/>
-          </a:fontRef>
-        </p:style>
-        <p:txBody>
-          <a:bodyPr rtlCol="0" anchor="ctr"/>
-          <a:lstStyle/>
-          <a:p>
-            <a:pPr algn="ctr"/>
-          </a:p>
-        </p:txBody>
-      </p:sp>
-      <p:sp>
-        <p:nvSpPr>
-          <p:cNvPr id="14" name="TextBox 13"/>
-          <p:cNvSpPr txBox="1"/>
-          <p:nvPr/>
-        </p:nvSpPr>
-        <p:spPr>
-          <a:xfrm>
-            <a:off x="1188720" y="5221224"/>
-            <a:ext cx="10332720" cy="411480"/>
-          </a:xfrm>
-          <a:prstGeom prst="rect">
-            <a:avLst/>
-          </a:prstGeom>
-          <a:noFill/>
-        </p:spPr>
-        <p:txBody>
-          <a:bodyPr wrap="square" lIns="0" rIns="0" tIns="0" bIns="0" anchor="t">
-            <a:spAutoFit/>
-          </a:bodyPr>
-          <a:lstStyle/>
-          <a:p>
-            <a:pPr algn="l">
-              <a:spcAft>
-                <a:spcPts val="600"/>
-              </a:spcAft>
-            </a:pPr>
-            <a:r>
-              <a:rPr sz="1700" b="1" i="0">
-                <a:solidFill>
-                  <a:srgbClr val="FFFFFF"/>
-                </a:solidFill>
-                <a:latin typeface="Cambria"/>
-              </a:rPr>
-              <a:t>Applicability must be tested, not assumed</a:t>
-            </a:r>
-          </a:p>
-        </p:txBody>
-      </p:sp>
-      <p:sp>
-        <p:nvSpPr>
-          <p:cNvPr id="15" name="TextBox 14"/>
-          <p:cNvSpPr txBox="1"/>
-          <p:nvPr/>
-        </p:nvSpPr>
-        <p:spPr>
-          <a:xfrm>
-            <a:off x="1188720" y="5678424"/>
-            <a:ext cx="10332720" cy="594360"/>
-          </a:xfrm>
-          <a:prstGeom prst="rect">
-            <a:avLst/>
-          </a:prstGeom>
-          <a:noFill/>
-        </p:spPr>
-        <p:txBody>
-          <a:bodyPr wrap="square" lIns="0" rIns="0" tIns="0" bIns="0" anchor="t">
-            <a:spAutoFit/>
-          </a:bodyPr>
-          <a:lstStyle/>
-          <a:p>
-            <a:pPr algn="l">
-              <a:spcAft>
-                <a:spcPts val="600"/>
-              </a:spcAft>
-            </a:pPr>
-            <a:r>
-              <a:rPr sz="1300" b="0" i="0">
-                <a:solidFill>
-                  <a:srgbClr val="B9CDDA"/>
-                </a:solidFill>
-                <a:latin typeface="Calibri"/>
-              </a:rPr>
-              <a:t>The three-VP test is undefined for non-Manhattan scenes; ignoring this reverses the verdict.</a:t>
-            </a:r>
-          </a:p>
-        </p:txBody>
-      </p:sp>
-      <p:sp>
-        <p:nvSpPr>
-          <p:cNvPr id="16" name="TextBox 15"/>
-          <p:cNvSpPr txBox="1"/>
-          <p:nvPr/>
-        </p:nvSpPr>
-        <p:spPr>
-          <a:xfrm>
-            <a:off x="685800" y="6355080"/>
-            <a:ext cx="10908792" cy="365760"/>
-          </a:xfrm>
-          <a:prstGeom prst="rect">
-            <a:avLst/>
-          </a:prstGeom>
-          <a:noFill/>
-        </p:spPr>
-        <p:txBody>
-          <a:bodyPr wrap="square" lIns="0" rIns="0" tIns="0" bIns="0" anchor="t">
-            <a:spAutoFit/>
-          </a:bodyPr>
-          <a:lstStyle/>
-          <a:p>
-            <a:pPr algn="l">
-              <a:spcAft>
-                <a:spcPts val="600"/>
-              </a:spcAft>
-            </a:pPr>
-            <a:r>
-              <a:rPr sz="1400" b="1" i="1">
-                <a:solidFill>
-                  <a:srgbClr val="E8A33D"/>
-                </a:solidFill>
-                <a:latin typeface="Calibri"/>
-              </a:rPr>
-              <a:t>Thesis: a generated image is locally photographic but has no single camera behind it.</a:t>
+              <a:t>A generated street scene whose three VP pairs imply focal lengths of 1626, 321 and 951 px — three different cameras in one image.</a:t>
             </a:r>
           </a:p>
         </p:txBody>
@@ -9818,303 +10081,6 @@
             <a:avLst/>
           </a:prstGeom>
           <a:solidFill>
-            <a:srgbClr val="FFFFFF"/>
-          </a:solidFill>
-          <a:ln>
-            <a:noFill/>
-          </a:ln>
-          <a:effectLst/>
-        </p:spPr>
-        <p:style>
-          <a:lnRef idx="1">
-            <a:schemeClr val="accent1"/>
-          </a:lnRef>
-          <a:fillRef idx="3">
-            <a:schemeClr val="accent1"/>
-          </a:fillRef>
-          <a:effectRef idx="2">
-            <a:schemeClr val="accent1"/>
-          </a:effectRef>
-          <a:fontRef idx="minor">
-            <a:schemeClr val="lt1"/>
-          </a:fontRef>
-        </p:style>
-        <p:txBody>
-          <a:bodyPr rtlCol="0" anchor="ctr"/>
-          <a:lstStyle/>
-          <a:p>
-            <a:pPr algn="ctr"/>
-          </a:p>
-        </p:txBody>
-      </p:sp>
-      <p:sp>
-        <p:nvSpPr>
-          <p:cNvPr id="3" name="TextBox 2"/>
-          <p:cNvSpPr txBox="1"/>
-          <p:nvPr/>
-        </p:nvSpPr>
-        <p:spPr>
-          <a:xfrm>
-            <a:off x="640080" y="457200"/>
-            <a:ext cx="10911535" cy="822960"/>
-          </a:xfrm>
-          <a:prstGeom prst="rect">
-            <a:avLst/>
-          </a:prstGeom>
-          <a:noFill/>
-        </p:spPr>
-        <p:txBody>
-          <a:bodyPr wrap="square" lIns="0" rIns="0" tIns="0" bIns="0" anchor="t">
-            <a:spAutoFit/>
-          </a:bodyPr>
-          <a:lstStyle/>
-          <a:p>
-            <a:pPr algn="l">
-              <a:spcAft>
-                <a:spcPts val="600"/>
-              </a:spcAft>
-            </a:pPr>
-            <a:r>
-              <a:rPr sz="3200" b="1" i="0">
-                <a:solidFill>
-                  <a:srgbClr val="12263A"/>
-                </a:solidFill>
-                <a:latin typeface="Cambria"/>
-              </a:rPr>
-              <a:t>Future Scope</a:t>
-            </a:r>
-          </a:p>
-        </p:txBody>
-      </p:sp>
-      <p:sp>
-        <p:nvSpPr>
-          <p:cNvPr id="4" name="Rounded Rectangle 3"/>
-          <p:cNvSpPr/>
-          <p:nvPr/>
-        </p:nvSpPr>
-        <p:spPr>
-          <a:xfrm>
-            <a:off x="640080" y="1920240"/>
-            <a:ext cx="3520440" cy="1874519"/>
-          </a:xfrm>
-          <a:prstGeom prst="roundRect">
-            <a:avLst>
-              <a:gd name="adj" fmla="val 6000"/>
-            </a:avLst>
-          </a:prstGeom>
-          <a:solidFill>
-            <a:srgbClr val="F4F6F8"/>
-          </a:solidFill>
-          <a:ln>
-            <a:noFill/>
-          </a:ln>
-          <a:effectLst/>
-        </p:spPr>
-        <p:style>
-          <a:lnRef idx="1">
-            <a:schemeClr val="accent1"/>
-          </a:lnRef>
-          <a:fillRef idx="3">
-            <a:schemeClr val="accent1"/>
-          </a:fillRef>
-          <a:effectRef idx="2">
-            <a:schemeClr val="accent1"/>
-          </a:effectRef>
-          <a:fontRef idx="minor">
-            <a:schemeClr val="lt1"/>
-          </a:fontRef>
-        </p:style>
-        <p:txBody>
-          <a:bodyPr rtlCol="0" anchor="ctr"/>
-          <a:lstStyle/>
-          <a:p>
-            <a:pPr algn="ctr"/>
-          </a:p>
-        </p:txBody>
-      </p:sp>
-      <p:sp>
-        <p:nvSpPr>
-          <p:cNvPr id="5" name="Oval 4"/>
-          <p:cNvSpPr/>
-          <p:nvPr/>
-        </p:nvSpPr>
-        <p:spPr>
-          <a:xfrm>
-            <a:off x="914400" y="2176272"/>
-            <a:ext cx="329184" cy="329184"/>
-          </a:xfrm>
-          <a:prstGeom prst="ellipse">
-            <a:avLst/>
-          </a:prstGeom>
-          <a:solidFill>
-            <a:srgbClr val="1C7293"/>
-          </a:solidFill>
-          <a:ln>
-            <a:noFill/>
-          </a:ln>
-          <a:effectLst/>
-        </p:spPr>
-        <p:style>
-          <a:lnRef idx="1">
-            <a:schemeClr val="accent1"/>
-          </a:lnRef>
-          <a:fillRef idx="3">
-            <a:schemeClr val="accent1"/>
-          </a:fillRef>
-          <a:effectRef idx="2">
-            <a:schemeClr val="accent1"/>
-          </a:effectRef>
-          <a:fontRef idx="minor">
-            <a:schemeClr val="lt1"/>
-          </a:fontRef>
-        </p:style>
-        <p:txBody>
-          <a:bodyPr rtlCol="0" anchor="ctr"/>
-          <a:lstStyle/>
-          <a:p>
-            <a:pPr algn="ctr"/>
-          </a:p>
-        </p:txBody>
-      </p:sp>
-      <p:sp>
-        <p:nvSpPr>
-          <p:cNvPr id="6" name="TextBox 5"/>
-          <p:cNvSpPr txBox="1"/>
-          <p:nvPr/>
-        </p:nvSpPr>
-        <p:spPr>
-          <a:xfrm>
-            <a:off x="1389888" y="2194560"/>
-            <a:ext cx="2560320" cy="365760"/>
-          </a:xfrm>
-          <a:prstGeom prst="rect">
-            <a:avLst/>
-          </a:prstGeom>
-          <a:noFill/>
-        </p:spPr>
-        <p:txBody>
-          <a:bodyPr wrap="square" lIns="0" rIns="0" tIns="0" bIns="0" anchor="t">
-            <a:spAutoFit/>
-          </a:bodyPr>
-          <a:lstStyle/>
-          <a:p>
-            <a:pPr algn="l">
-              <a:spcAft>
-                <a:spcPts val="600"/>
-              </a:spcAft>
-            </a:pPr>
-            <a:r>
-              <a:rPr sz="1450" b="1" i="0">
-                <a:solidFill>
-                  <a:srgbClr val="12263A"/>
-                </a:solidFill>
-                <a:latin typeface="Cambria"/>
-              </a:rPr>
-              <a:t>Frontier models</a:t>
-            </a:r>
-          </a:p>
-        </p:txBody>
-      </p:sp>
-      <p:sp>
-        <p:nvSpPr>
-          <p:cNvPr id="7" name="TextBox 6"/>
-          <p:cNvSpPr txBox="1"/>
-          <p:nvPr/>
-        </p:nvSpPr>
-        <p:spPr>
-          <a:xfrm>
-            <a:off x="914400" y="2697480"/>
-            <a:ext cx="2971800" cy="960120"/>
-          </a:xfrm>
-          <a:prstGeom prst="rect">
-            <a:avLst/>
-          </a:prstGeom>
-          <a:noFill/>
-        </p:spPr>
-        <p:txBody>
-          <a:bodyPr wrap="square" lIns="0" rIns="0" tIns="0" bIns="0" anchor="t">
-            <a:spAutoFit/>
-          </a:bodyPr>
-          <a:lstStyle/>
-          <a:p>
-            <a:pPr algn="l">
-              <a:spcAft>
-                <a:spcPts val="600"/>
-              </a:spcAft>
-            </a:pPr>
-            <a:r>
-              <a:rPr sz="1200" b="0" i="0">
-                <a:solidFill>
-                  <a:srgbClr val="5A6672"/>
-                </a:solidFill>
-                <a:latin typeface="Calibri"/>
-              </a:rPr>
-              <a:t>Gemini, GPT-image and FLUX on the same prompt set — prompts already exported and the analysis is model-agnostic.</a:t>
-            </a:r>
-          </a:p>
-        </p:txBody>
-      </p:sp>
-      <p:sp>
-        <p:nvSpPr>
-          <p:cNvPr id="8" name="Rounded Rectangle 7"/>
-          <p:cNvSpPr/>
-          <p:nvPr/>
-        </p:nvSpPr>
-        <p:spPr>
-          <a:xfrm>
-            <a:off x="4407408" y="1920240"/>
-            <a:ext cx="3520440" cy="1874519"/>
-          </a:xfrm>
-          <a:prstGeom prst="roundRect">
-            <a:avLst>
-              <a:gd name="adj" fmla="val 6000"/>
-            </a:avLst>
-          </a:prstGeom>
-          <a:solidFill>
-            <a:srgbClr val="F4F6F8"/>
-          </a:solidFill>
-          <a:ln>
-            <a:noFill/>
-          </a:ln>
-          <a:effectLst/>
-        </p:spPr>
-        <p:style>
-          <a:lnRef idx="1">
-            <a:schemeClr val="accent1"/>
-          </a:lnRef>
-          <a:fillRef idx="3">
-            <a:schemeClr val="accent1"/>
-          </a:fillRef>
-          <a:effectRef idx="2">
-            <a:schemeClr val="accent1"/>
-          </a:effectRef>
-          <a:fontRef idx="minor">
-            <a:schemeClr val="lt1"/>
-          </a:fontRef>
-        </p:style>
-        <p:txBody>
-          <a:bodyPr rtlCol="0" anchor="ctr"/>
-          <a:lstStyle/>
-          <a:p>
-            <a:pPr algn="ctr"/>
-          </a:p>
-        </p:txBody>
-      </p:sp>
-      <p:sp>
-        <p:nvSpPr>
-          <p:cNvPr id="9" name="Oval 8"/>
-          <p:cNvSpPr/>
-          <p:nvPr/>
-        </p:nvSpPr>
-        <p:spPr>
-          <a:xfrm>
-            <a:off x="4681728" y="2176272"/>
-            <a:ext cx="329184" cy="329184"/>
-          </a:xfrm>
-          <a:prstGeom prst="ellipse">
-            <a:avLst/>
-          </a:prstGeom>
-          <a:solidFill>
             <a:srgbClr val="12263A"/>
           </a:solidFill>
           <a:ln>
@@ -10146,14 +10112,14 @@
       </p:sp>
       <p:sp>
         <p:nvSpPr>
-          <p:cNvPr id="10" name="TextBox 9"/>
+          <p:cNvPr id="3" name="TextBox 2"/>
           <p:cNvSpPr txBox="1"/>
           <p:nvPr/>
         </p:nvSpPr>
         <p:spPr>
           <a:xfrm>
-            <a:off x="5157216" y="2194560"/>
-            <a:ext cx="2560320" cy="365760"/>
+            <a:off x="640080" y="457200"/>
+            <a:ext cx="10911535" cy="822960"/>
           </a:xfrm>
           <a:prstGeom prst="rect">
             <a:avLst/>
@@ -10172,280 +10138,27 @@
               </a:spcAft>
             </a:pPr>
             <a:r>
-              <a:rPr sz="1450" b="1" i="0">
-                <a:solidFill>
-                  <a:srgbClr val="12263A"/>
+              <a:rPr sz="3200" b="1" i="0">
+                <a:solidFill>
+                  <a:srgbClr val="FFFFFF"/>
                 </a:solidFill>
                 <a:latin typeface="Cambria"/>
               </a:rPr>
-              <a:t>Shadow association</a:t>
-            </a:r>
-          </a:p>
-        </p:txBody>
-      </p:sp>
-      <p:sp>
-        <p:nvSpPr>
-          <p:cNvPr id="11" name="TextBox 10"/>
-          <p:cNvSpPr txBox="1"/>
-          <p:nvPr/>
-        </p:nvSpPr>
-        <p:spPr>
-          <a:xfrm>
-            <a:off x="4681728" y="2697480"/>
-            <a:ext cx="2971800" cy="960120"/>
-          </a:xfrm>
-          <a:prstGeom prst="rect">
-            <a:avLst/>
-          </a:prstGeom>
-          <a:noFill/>
-        </p:spPr>
-        <p:txBody>
-          <a:bodyPr wrap="square" lIns="0" rIns="0" tIns="0" bIns="0" anchor="t">
-            <a:spAutoFit/>
-          </a:bodyPr>
-          <a:lstStyle/>
-          <a:p>
-            <a:pPr algn="l">
-              <a:spcAft>
-                <a:spcPts val="600"/>
-              </a:spcAft>
-            </a:pPr>
-            <a:r>
-              <a:rPr sz="1200" b="0" i="0">
-                <a:solidFill>
-                  <a:srgbClr val="5A6672"/>
-                </a:solidFill>
-                <a:latin typeface="Calibri"/>
-              </a:rPr>
-              <a:t>SSIS or SAM 2 for object-shadow pairs; the wedge LP above it is built and validated.</a:t>
-            </a:r>
-          </a:p>
-        </p:txBody>
-      </p:sp>
-      <p:sp>
-        <p:nvSpPr>
-          <p:cNvPr id="12" name="Rounded Rectangle 11"/>
+              <a:t>Conclusion</a:t>
+            </a:r>
+          </a:p>
+        </p:txBody>
+      </p:sp>
+      <p:sp>
+        <p:nvSpPr>
+          <p:cNvPr id="4" name="Oval 3"/>
           <p:cNvSpPr/>
           <p:nvPr/>
         </p:nvSpPr>
         <p:spPr>
           <a:xfrm>
-            <a:off x="8174736" y="1920240"/>
-            <a:ext cx="3520440" cy="1874519"/>
-          </a:xfrm>
-          <a:prstGeom prst="roundRect">
-            <a:avLst>
-              <a:gd name="adj" fmla="val 6000"/>
-            </a:avLst>
-          </a:prstGeom>
-          <a:solidFill>
-            <a:srgbClr val="F4F6F8"/>
-          </a:solidFill>
-          <a:ln>
-            <a:noFill/>
-          </a:ln>
-          <a:effectLst/>
-        </p:spPr>
-        <p:style>
-          <a:lnRef idx="1">
-            <a:schemeClr val="accent1"/>
-          </a:lnRef>
-          <a:fillRef idx="3">
-            <a:schemeClr val="accent1"/>
-          </a:fillRef>
-          <a:effectRef idx="2">
-            <a:schemeClr val="accent1"/>
-          </a:effectRef>
-          <a:fontRef idx="minor">
-            <a:schemeClr val="lt1"/>
-          </a:fontRef>
-        </p:style>
-        <p:txBody>
-          <a:bodyPr rtlCol="0" anchor="ctr"/>
-          <a:lstStyle/>
-          <a:p>
-            <a:pPr algn="ctr"/>
-          </a:p>
-        </p:txBody>
-      </p:sp>
-      <p:sp>
-        <p:nvSpPr>
-          <p:cNvPr id="13" name="Oval 12"/>
-          <p:cNvSpPr/>
-          <p:nvPr/>
-        </p:nvSpPr>
-        <p:spPr>
-          <a:xfrm>
-            <a:off x="8449056" y="2176272"/>
-            <a:ext cx="329184" cy="329184"/>
-          </a:xfrm>
-          <a:prstGeom prst="ellipse">
-            <a:avLst/>
-          </a:prstGeom>
-          <a:solidFill>
-            <a:srgbClr val="1C7293"/>
-          </a:solidFill>
-          <a:ln>
-            <a:noFill/>
-          </a:ln>
-          <a:effectLst/>
-        </p:spPr>
-        <p:style>
-          <a:lnRef idx="1">
-            <a:schemeClr val="accent1"/>
-          </a:lnRef>
-          <a:fillRef idx="3">
-            <a:schemeClr val="accent1"/>
-          </a:fillRef>
-          <a:effectRef idx="2">
-            <a:schemeClr val="accent1"/>
-          </a:effectRef>
-          <a:fontRef idx="minor">
-            <a:schemeClr val="lt1"/>
-          </a:fontRef>
-        </p:style>
-        <p:txBody>
-          <a:bodyPr rtlCol="0" anchor="ctr"/>
-          <a:lstStyle/>
-          <a:p>
-            <a:pPr algn="ctr"/>
-          </a:p>
-        </p:txBody>
-      </p:sp>
-      <p:sp>
-        <p:nvSpPr>
-          <p:cNvPr id="14" name="TextBox 13"/>
-          <p:cNvSpPr txBox="1"/>
-          <p:nvPr/>
-        </p:nvSpPr>
-        <p:spPr>
-          <a:xfrm>
-            <a:off x="8924544" y="2194560"/>
-            <a:ext cx="2560320" cy="365760"/>
-          </a:xfrm>
-          <a:prstGeom prst="rect">
-            <a:avLst/>
-          </a:prstGeom>
-          <a:noFill/>
-        </p:spPr>
-        <p:txBody>
-          <a:bodyPr wrap="square" lIns="0" rIns="0" tIns="0" bIns="0" anchor="t">
-            <a:spAutoFit/>
-          </a:bodyPr>
-          <a:lstStyle/>
-          <a:p>
-            <a:pPr algn="l">
-              <a:spcAft>
-                <a:spcPts val="600"/>
-              </a:spcAft>
-            </a:pPr>
-            <a:r>
-              <a:rPr sz="1450" b="1" i="0">
-                <a:solidFill>
-                  <a:srgbClr val="12263A"/>
-                </a:solidFill>
-                <a:latin typeface="Cambria"/>
-              </a:rPr>
-              <a:t>Remaining levels</a:t>
-            </a:r>
-          </a:p>
-        </p:txBody>
-      </p:sp>
-      <p:sp>
-        <p:nvSpPr>
-          <p:cNvPr id="15" name="TextBox 14"/>
-          <p:cNvSpPr txBox="1"/>
-          <p:nvPr/>
-        </p:nvSpPr>
-        <p:spPr>
-          <a:xfrm>
-            <a:off x="8449056" y="2697480"/>
-            <a:ext cx="2971800" cy="960120"/>
-          </a:xfrm>
-          <a:prstGeom prst="rect">
-            <a:avLst/>
-          </a:prstGeom>
-          <a:noFill/>
-        </p:spPr>
-        <p:txBody>
-          <a:bodyPr wrap="square" lIns="0" rIns="0" tIns="0" bIns="0" anchor="t">
-            <a:spAutoFit/>
-          </a:bodyPr>
-          <a:lstStyle/>
-          <a:p>
-            <a:pPr algn="l">
-              <a:spcAft>
-                <a:spcPts val="600"/>
-              </a:spcAft>
-            </a:pPr>
-            <a:r>
-              <a:rPr sz="1200" b="0" i="0">
-                <a:solidFill>
-                  <a:srgbClr val="5A6672"/>
-                </a:solidFill>
-                <a:latin typeface="Calibri"/>
-              </a:rPr>
-              <a:t>Cross-ratio, conics, reflections and cross-modal normal agreement.</a:t>
-            </a:r>
-          </a:p>
-        </p:txBody>
-      </p:sp>
-      <p:sp>
-        <p:nvSpPr>
-          <p:cNvPr id="16" name="Rounded Rectangle 15"/>
-          <p:cNvSpPr/>
-          <p:nvPr/>
-        </p:nvSpPr>
-        <p:spPr>
-          <a:xfrm>
-            <a:off x="640080" y="4114800"/>
-            <a:ext cx="3520440" cy="1874519"/>
-          </a:xfrm>
-          <a:prstGeom prst="roundRect">
-            <a:avLst>
-              <a:gd name="adj" fmla="val 6000"/>
-            </a:avLst>
-          </a:prstGeom>
-          <a:solidFill>
-            <a:srgbClr val="F4F6F8"/>
-          </a:solidFill>
-          <a:ln>
-            <a:noFill/>
-          </a:ln>
-          <a:effectLst/>
-        </p:spPr>
-        <p:style>
-          <a:lnRef idx="1">
-            <a:schemeClr val="accent1"/>
-          </a:lnRef>
-          <a:fillRef idx="3">
-            <a:schemeClr val="accent1"/>
-          </a:fillRef>
-          <a:effectRef idx="2">
-            <a:schemeClr val="accent1"/>
-          </a:effectRef>
-          <a:fontRef idx="minor">
-            <a:schemeClr val="lt1"/>
-          </a:fontRef>
-        </p:style>
-        <p:txBody>
-          <a:bodyPr rtlCol="0" anchor="ctr"/>
-          <a:lstStyle/>
-          <a:p>
-            <a:pPr algn="ctr"/>
-          </a:p>
-        </p:txBody>
-      </p:sp>
-      <p:sp>
-        <p:nvSpPr>
-          <p:cNvPr id="17" name="Oval 16"/>
-          <p:cNvSpPr/>
-          <p:nvPr/>
-        </p:nvSpPr>
-        <p:spPr>
-          <a:xfrm>
-            <a:off x="914400" y="4370832"/>
-            <a:ext cx="329184" cy="329184"/>
+            <a:off x="685800" y="1984248"/>
+            <a:ext cx="274320" cy="274320"/>
           </a:xfrm>
           <a:prstGeom prst="ellipse">
             <a:avLst/>
@@ -10482,14 +10195,14 @@
       </p:sp>
       <p:sp>
         <p:nvSpPr>
-          <p:cNvPr id="18" name="TextBox 17"/>
+          <p:cNvPr id="5" name="TextBox 4"/>
           <p:cNvSpPr txBox="1"/>
           <p:nvPr/>
         </p:nvSpPr>
         <p:spPr>
           <a:xfrm>
-            <a:off x="1389888" y="4389120"/>
-            <a:ext cx="2560320" cy="365760"/>
+            <a:off x="1188720" y="1874519"/>
+            <a:ext cx="10332720" cy="411480"/>
           </a:xfrm>
           <a:prstGeom prst="rect">
             <a:avLst/>
@@ -10508,27 +10221,27 @@
               </a:spcAft>
             </a:pPr>
             <a:r>
-              <a:rPr sz="1450" b="1" i="0">
-                <a:solidFill>
-                  <a:srgbClr val="12263A"/>
+              <a:rPr sz="1700" b="1" i="0">
+                <a:solidFill>
+                  <a:srgbClr val="FFFFFF"/>
                 </a:solidFill>
                 <a:latin typeface="Cambria"/>
               </a:rPr>
-              <a:t>Mechanism</a:t>
-            </a:r>
-          </a:p>
-        </p:txBody>
-      </p:sp>
-      <p:sp>
-        <p:nvSpPr>
-          <p:cNvPr id="19" name="TextBox 18"/>
+              <a:t>Generators reproduce orientation, not the camera</a:t>
+            </a:r>
+          </a:p>
+        </p:txBody>
+      </p:sp>
+      <p:sp>
+        <p:nvSpPr>
+          <p:cNvPr id="6" name="TextBox 5"/>
           <p:cNvSpPr txBox="1"/>
           <p:nvPr/>
         </p:nvSpPr>
         <p:spPr>
           <a:xfrm>
-            <a:off x="914400" y="4892040"/>
-            <a:ext cx="2971800" cy="960120"/>
+            <a:off x="1188720" y="2331720"/>
+            <a:ext cx="10332720" cy="594360"/>
           </a:xfrm>
           <a:prstGeom prst="rect">
             <a:avLst/>
@@ -10547,35 +10260,33 @@
               </a:spcAft>
             </a:pPr>
             <a:r>
-              <a:rPr sz="1200" b="0" i="0">
-                <a:solidFill>
-                  <a:srgbClr val="5A6672"/>
+              <a:rPr sz="1300" b="0" i="0">
+                <a:solidFill>
+                  <a:srgbClr val="B9CDDA"/>
                 </a:solidFill>
                 <a:latin typeface="Calibri"/>
               </a:rPr>
-              <a:t>Why does scale not fix camera coherence? Aspect ratio is ruled out; resolution and latent receptive field remain.</a:t>
-            </a:r>
-          </a:p>
-        </p:txBody>
-      </p:sp>
-      <p:sp>
-        <p:nvSpPr>
-          <p:cNvPr id="20" name="Rounded Rectangle 19"/>
+              <a:t>Manhattan orthogonality is comparable to real photographs after control; focal and principal-point coherence is 2.5-3× worse.</a:t>
+            </a:r>
+          </a:p>
+        </p:txBody>
+      </p:sp>
+      <p:sp>
+        <p:nvSpPr>
+          <p:cNvPr id="7" name="Oval 6"/>
           <p:cNvSpPr/>
           <p:nvPr/>
         </p:nvSpPr>
         <p:spPr>
           <a:xfrm>
-            <a:off x="4407408" y="4114800"/>
-            <a:ext cx="3520440" cy="1874519"/>
-          </a:xfrm>
-          <a:prstGeom prst="roundRect">
-            <a:avLst>
-              <a:gd name="adj" fmla="val 6000"/>
-            </a:avLst>
+            <a:off x="685800" y="3099815"/>
+            <a:ext cx="274320" cy="274320"/>
+          </a:xfrm>
+          <a:prstGeom prst="ellipse">
+            <a:avLst/>
           </a:prstGeom>
           <a:solidFill>
-            <a:srgbClr val="F4F6F8"/>
+            <a:srgbClr val="E8A33D"/>
           </a:solidFill>
           <a:ln>
             <a:noFill/>
@@ -10606,20 +10317,98 @@
       </p:sp>
       <p:sp>
         <p:nvSpPr>
-          <p:cNvPr id="21" name="Oval 20"/>
+          <p:cNvPr id="8" name="TextBox 7"/>
+          <p:cNvSpPr txBox="1"/>
+          <p:nvPr/>
+        </p:nvSpPr>
+        <p:spPr>
+          <a:xfrm>
+            <a:off x="1188720" y="2990087"/>
+            <a:ext cx="10332720" cy="411480"/>
+          </a:xfrm>
+          <a:prstGeom prst="rect">
+            <a:avLst/>
+          </a:prstGeom>
+          <a:noFill/>
+        </p:spPr>
+        <p:txBody>
+          <a:bodyPr wrap="square" lIns="0" rIns="0" tIns="0" bIns="0" anchor="t">
+            <a:spAutoFit/>
+          </a:bodyPr>
+          <a:lstStyle/>
+          <a:p>
+            <a:pPr algn="l">
+              <a:spcAft>
+                <a:spcPts val="600"/>
+              </a:spcAft>
+            </a:pPr>
+            <a:r>
+              <a:rPr sz="1700" b="1" i="0">
+                <a:solidFill>
+                  <a:srgbClr val="FFFFFF"/>
+                </a:solidFill>
+                <a:latin typeface="Cambria"/>
+              </a:rPr>
+              <a:t>The result is robust to the real reference</a:t>
+            </a:r>
+          </a:p>
+        </p:txBody>
+      </p:sp>
+      <p:sp>
+        <p:nvSpPr>
+          <p:cNvPr id="9" name="TextBox 8"/>
+          <p:cNvSpPr txBox="1"/>
+          <p:nvPr/>
+        </p:nvSpPr>
+        <p:spPr>
+          <a:xfrm>
+            <a:off x="1188720" y="3447287"/>
+            <a:ext cx="10332720" cy="594360"/>
+          </a:xfrm>
+          <a:prstGeom prst="rect">
+            <a:avLst/>
+          </a:prstGeom>
+          <a:noFill/>
+        </p:spPr>
+        <p:txBody>
+          <a:bodyPr wrap="square" lIns="0" rIns="0" tIns="0" bIns="0" anchor="t">
+            <a:spAutoFit/>
+          </a:bodyPr>
+          <a:lstStyle/>
+          <a:p>
+            <a:pPr algn="l">
+              <a:spcAft>
+                <a:spcPts val="600"/>
+              </a:spcAft>
+            </a:pPr>
+            <a:r>
+              <a:rPr sz="1300" b="0" i="0">
+                <a:solidFill>
+                  <a:srgbClr val="B9CDDA"/>
+                </a:solidFill>
+                <a:latin typeface="Calibri"/>
+              </a:rPr>
+              <a:t>Both a curated benchmark and uncurated internet photographs give the same conclusion, with non-overlapping confidence intervals.</a:t>
+            </a:r>
+          </a:p>
+        </p:txBody>
+      </p:sp>
+      <p:sp>
+        <p:nvSpPr>
+          <p:cNvPr id="10" name="Oval 9"/>
           <p:cNvSpPr/>
           <p:nvPr/>
         </p:nvSpPr>
         <p:spPr>
           <a:xfrm>
-            <a:off x="4681728" y="4370832"/>
-            <a:ext cx="329184" cy="329184"/>
+            <a:off x="685800" y="4215384"/>
+            <a:ext cx="274320" cy="274320"/>
           </a:xfrm>
           <a:prstGeom prst="ellipse">
             <a:avLst/>
           </a:prstGeom>
           <a:solidFill>
-            <a:srgbClr val="12263A"/>
+            <a:srgbClr val="E8A33D"/>
           </a:solidFill>
           <a:ln>
             <a:noFill/>
@@ -10650,14 +10439,14 @@
       </p:sp>
       <p:sp>
         <p:nvSpPr>
-          <p:cNvPr id="22" name="TextBox 21"/>
+          <p:cNvPr id="11" name="TextBox 10"/>
           <p:cNvSpPr txBox="1"/>
           <p:nvPr/>
         </p:nvSpPr>
         <p:spPr>
           <a:xfrm>
-            <a:off x="5157216" y="4389120"/>
-            <a:ext cx="2560320" cy="365760"/>
+            <a:off x="1188720" y="4105656"/>
+            <a:ext cx="10332720" cy="411480"/>
           </a:xfrm>
           <a:prstGeom prst="rect">
             <a:avLst/>
@@ -10676,27 +10465,27 @@
               </a:spcAft>
             </a:pPr>
             <a:r>
-              <a:rPr sz="1450" b="1" i="0">
-                <a:solidFill>
-                  <a:srgbClr val="12263A"/>
+              <a:rPr sz="1700" b="1" i="0">
+                <a:solidFill>
+                  <a:srgbClr val="FFFFFF"/>
                 </a:solidFill>
                 <a:latin typeface="Cambria"/>
               </a:rPr>
-              <a:t>Sheaf formalism</a:t>
-            </a:r>
-          </a:p>
-        </p:txBody>
-      </p:sp>
-      <p:sp>
-        <p:nvSpPr>
-          <p:cNvPr id="23" name="TextBox 22"/>
+              <a:t>Scale is not closing the gap</a:t>
+            </a:r>
+          </a:p>
+        </p:txBody>
+      </p:sp>
+      <p:sp>
+        <p:nvSpPr>
+          <p:cNvPr id="12" name="TextBox 11"/>
           <p:cNvSpPr txBox="1"/>
           <p:nvPr/>
         </p:nvSpPr>
         <p:spPr>
           <a:xfrm>
-            <a:off x="4681728" y="4892040"/>
-            <a:ext cx="2971800" cy="960120"/>
+            <a:off x="1188720" y="4562856"/>
+            <a:ext cx="10332720" cy="594360"/>
           </a:xfrm>
           <a:prstGeom prst="rect">
             <a:avLst/>
@@ -10715,35 +10504,33 @@
               </a:spcAft>
             </a:pPr>
             <a:r>
-              <a:rPr sz="1200" b="0" i="0">
-                <a:solidFill>
-                  <a:srgbClr val="5A6672"/>
+              <a:rPr sz="1300" b="0" i="0">
+                <a:solidFill>
+                  <a:srgbClr val="B9CDDA"/>
                 </a:solidFill>
                 <a:latin typeface="Calibri"/>
               </a:rPr>
-              <a:t>Consistency radius over a cover of local cameras as a principled local-to-global measure.</a:t>
-            </a:r>
-          </a:p>
-        </p:txBody>
-      </p:sp>
-      <p:sp>
-        <p:nvSpPr>
-          <p:cNvPr id="24" name="Rounded Rectangle 23"/>
+              <a:t>SD 1.5 → SDXL improves orientation significantly and leaves camera coherence unchanged.</a:t>
+            </a:r>
+          </a:p>
+        </p:txBody>
+      </p:sp>
+      <p:sp>
+        <p:nvSpPr>
+          <p:cNvPr id="13" name="Oval 12"/>
           <p:cNvSpPr/>
           <p:nvPr/>
         </p:nvSpPr>
         <p:spPr>
           <a:xfrm>
-            <a:off x="8174736" y="4114800"/>
-            <a:ext cx="3520440" cy="1874519"/>
-          </a:xfrm>
-          <a:prstGeom prst="roundRect">
-            <a:avLst>
-              <a:gd name="adj" fmla="val 6000"/>
-            </a:avLst>
+            <a:off x="685800" y="5330952"/>
+            <a:ext cx="274320" cy="274320"/>
+          </a:xfrm>
+          <a:prstGeom prst="ellipse">
+            <a:avLst/>
           </a:prstGeom>
           <a:solidFill>
-            <a:srgbClr val="F4F6F8"/>
+            <a:srgbClr val="E8A33D"/>
           </a:solidFill>
           <a:ln>
             <a:noFill/>
@@ -10774,58 +10561,14 @@
       </p:sp>
       <p:sp>
         <p:nvSpPr>
-          <p:cNvPr id="25" name="Oval 24"/>
-          <p:cNvSpPr/>
-          <p:nvPr/>
-        </p:nvSpPr>
-        <p:spPr>
-          <a:xfrm>
-            <a:off x="8449056" y="4370832"/>
-            <a:ext cx="329184" cy="329184"/>
-          </a:xfrm>
-          <a:prstGeom prst="ellipse">
-            <a:avLst/>
-          </a:prstGeom>
-          <a:solidFill>
-            <a:srgbClr val="1C7293"/>
-          </a:solidFill>
-          <a:ln>
-            <a:noFill/>
-          </a:ln>
-          <a:effectLst/>
-        </p:spPr>
-        <p:style>
-          <a:lnRef idx="1">
-            <a:schemeClr val="accent1"/>
-          </a:lnRef>
-          <a:fillRef idx="3">
-            <a:schemeClr val="accent1"/>
-          </a:fillRef>
-          <a:effectRef idx="2">
-            <a:schemeClr val="accent1"/>
-          </a:effectRef>
-          <a:fontRef idx="minor">
-            <a:schemeClr val="lt1"/>
-          </a:fontRef>
-        </p:style>
-        <p:txBody>
-          <a:bodyPr rtlCol="0" anchor="ctr"/>
-          <a:lstStyle/>
-          <a:p>
-            <a:pPr algn="ctr"/>
-          </a:p>
-        </p:txBody>
-      </p:sp>
-      <p:sp>
-        <p:nvSpPr>
-          <p:cNvPr id="26" name="TextBox 25"/>
+          <p:cNvPr id="14" name="TextBox 13"/>
           <p:cNvSpPr txBox="1"/>
           <p:nvPr/>
         </p:nvSpPr>
         <p:spPr>
           <a:xfrm>
-            <a:off x="8924544" y="4389120"/>
-            <a:ext cx="2560320" cy="365760"/>
+            <a:off x="1188720" y="5221224"/>
+            <a:ext cx="10332720" cy="411480"/>
           </a:xfrm>
           <a:prstGeom prst="rect">
             <a:avLst/>
@@ -10844,27 +10587,27 @@
               </a:spcAft>
             </a:pPr>
             <a:r>
-              <a:rPr sz="1450" b="1" i="0">
-                <a:solidFill>
-                  <a:srgbClr val="12263A"/>
+              <a:rPr sz="1700" b="1" i="0">
+                <a:solidFill>
+                  <a:srgbClr val="FFFFFF"/>
                 </a:solidFill>
                 <a:latin typeface="Cambria"/>
               </a:rPr>
-              <a:t>Perception study</a:t>
-            </a:r>
-          </a:p>
-        </p:txBody>
-      </p:sp>
-      <p:sp>
-        <p:nvSpPr>
-          <p:cNvPr id="27" name="TextBox 26"/>
+              <a:t>Applicability must be tested, not assumed</a:t>
+            </a:r>
+          </a:p>
+        </p:txBody>
+      </p:sp>
+      <p:sp>
+        <p:nvSpPr>
+          <p:cNvPr id="15" name="TextBox 14"/>
           <p:cNvSpPr txBox="1"/>
           <p:nvPr/>
         </p:nvSpPr>
         <p:spPr>
           <a:xfrm>
-            <a:off x="8449056" y="4892040"/>
-            <a:ext cx="2971800" cy="960120"/>
+            <a:off x="1188720" y="5678424"/>
+            <a:ext cx="10332720" cy="594360"/>
           </a:xfrm>
           <a:prstGeom prst="rect">
             <a:avLst/>
@@ -10883,13 +10626,52 @@
               </a:spcAft>
             </a:pPr>
             <a:r>
-              <a:rPr sz="1200" b="0" i="0">
-                <a:solidFill>
-                  <a:srgbClr val="5A6672"/>
+              <a:rPr sz="1300" b="0" i="0">
+                <a:solidFill>
+                  <a:srgbClr val="B9CDDA"/>
                 </a:solidFill>
                 <a:latin typeface="Calibri"/>
               </a:rPr>
-              <a:t>Which violations are mathematically severe but visually unnoticed.</a:t>
+              <a:t>The three-VP test is undefined for non-Manhattan scenes; ignoring this reverses the verdict.</a:t>
+            </a:r>
+          </a:p>
+        </p:txBody>
+      </p:sp>
+      <p:sp>
+        <p:nvSpPr>
+          <p:cNvPr id="16" name="TextBox 15"/>
+          <p:cNvSpPr txBox="1"/>
+          <p:nvPr/>
+        </p:nvSpPr>
+        <p:spPr>
+          <a:xfrm>
+            <a:off x="685800" y="6355080"/>
+            <a:ext cx="10908792" cy="365760"/>
+          </a:xfrm>
+          <a:prstGeom prst="rect">
+            <a:avLst/>
+          </a:prstGeom>
+          <a:noFill/>
+        </p:spPr>
+        <p:txBody>
+          <a:bodyPr wrap="square" lIns="0" rIns="0" tIns="0" bIns="0" anchor="t">
+            <a:spAutoFit/>
+          </a:bodyPr>
+          <a:lstStyle/>
+          <a:p>
+            <a:pPr algn="l">
+              <a:spcAft>
+                <a:spcPts val="600"/>
+              </a:spcAft>
+            </a:pPr>
+            <a:r>
+              <a:rPr sz="1400" b="1" i="1">
+                <a:solidFill>
+                  <a:srgbClr val="E8A33D"/>
+                </a:solidFill>
+                <a:latin typeface="Calibri"/>
+              </a:rPr>
+              <a:t>Thesis: a generated image is locally photographic but has no single camera behind it.</a:t>
             </a:r>
           </a:p>
         </p:txBody>
@@ -10990,220 +10772,111 @@
                 </a:solidFill>
                 <a:latin typeface="Cambria"/>
               </a:rPr>
-              <a:t>References</a:t>
-            </a:r>
-          </a:p>
-        </p:txBody>
-      </p:sp>
-      <p:sp>
-        <p:nvSpPr>
-          <p:cNvPr id="4" name="TextBox 3"/>
+              <a:t>Future Scope</a:t>
+            </a:r>
+          </a:p>
+        </p:txBody>
+      </p:sp>
+      <p:sp>
+        <p:nvSpPr>
+          <p:cNvPr id="4" name="Rounded Rectangle 3"/>
+          <p:cNvSpPr/>
+          <p:nvPr/>
+        </p:nvSpPr>
+        <p:spPr>
+          <a:xfrm>
+            <a:off x="640080" y="1920240"/>
+            <a:ext cx="3520440" cy="1874519"/>
+          </a:xfrm>
+          <a:prstGeom prst="roundRect">
+            <a:avLst>
+              <a:gd name="adj" fmla="val 6000"/>
+            </a:avLst>
+          </a:prstGeom>
+          <a:solidFill>
+            <a:srgbClr val="F4F6F8"/>
+          </a:solidFill>
+          <a:ln>
+            <a:noFill/>
+          </a:ln>
+          <a:effectLst/>
+        </p:spPr>
+        <p:style>
+          <a:lnRef idx="1">
+            <a:schemeClr val="accent1"/>
+          </a:lnRef>
+          <a:fillRef idx="3">
+            <a:schemeClr val="accent1"/>
+          </a:fillRef>
+          <a:effectRef idx="2">
+            <a:schemeClr val="accent1"/>
+          </a:effectRef>
+          <a:fontRef idx="minor">
+            <a:schemeClr val="lt1"/>
+          </a:fontRef>
+        </p:style>
+        <p:txBody>
+          <a:bodyPr rtlCol="0" anchor="ctr"/>
+          <a:lstStyle/>
+          <a:p>
+            <a:pPr algn="ctr"/>
+          </a:p>
+        </p:txBody>
+      </p:sp>
+      <p:sp>
+        <p:nvSpPr>
+          <p:cNvPr id="5" name="Oval 4"/>
+          <p:cNvSpPr/>
+          <p:nvPr/>
+        </p:nvSpPr>
+        <p:spPr>
+          <a:xfrm>
+            <a:off x="914400" y="2176272"/>
+            <a:ext cx="329184" cy="329184"/>
+          </a:xfrm>
+          <a:prstGeom prst="ellipse">
+            <a:avLst/>
+          </a:prstGeom>
+          <a:solidFill>
+            <a:srgbClr val="1C7293"/>
+          </a:solidFill>
+          <a:ln>
+            <a:noFill/>
+          </a:ln>
+          <a:effectLst/>
+        </p:spPr>
+        <p:style>
+          <a:lnRef idx="1">
+            <a:schemeClr val="accent1"/>
+          </a:lnRef>
+          <a:fillRef idx="3">
+            <a:schemeClr val="accent1"/>
+          </a:fillRef>
+          <a:effectRef idx="2">
+            <a:schemeClr val="accent1"/>
+          </a:effectRef>
+          <a:fontRef idx="minor">
+            <a:schemeClr val="lt1"/>
+          </a:fontRef>
+        </p:style>
+        <p:txBody>
+          <a:bodyPr rtlCol="0" anchor="ctr"/>
+          <a:lstStyle/>
+          <a:p>
+            <a:pPr algn="ctr"/>
+          </a:p>
+        </p:txBody>
+      </p:sp>
+      <p:sp>
+        <p:nvSpPr>
+          <p:cNvPr id="6" name="TextBox 5"/>
           <p:cNvSpPr txBox="1"/>
           <p:nvPr/>
         </p:nvSpPr>
         <p:spPr>
           <a:xfrm>
-            <a:off x="640080" y="1783080"/>
-            <a:ext cx="10908792" cy="4480560"/>
-          </a:xfrm>
-          <a:prstGeom prst="rect">
-            <a:avLst/>
-          </a:prstGeom>
-          <a:noFill/>
-        </p:spPr>
-        <p:txBody>
-          <a:bodyPr wrap="square" lIns="0" rIns="0">
-            <a:spAutoFit/>
-          </a:bodyPr>
-          <a:lstStyle/>
-          <a:p>
-            <a:pPr>
-              <a:spcAft>
-                <a:spcPts val="700"/>
-              </a:spcAft>
-            </a:pPr>
-            <a:r>
-              <a:rPr sz="1200">
-                <a:solidFill>
-                  <a:srgbClr val="1A1A1A"/>
-                </a:solidFill>
-                <a:latin typeface="Calibri"/>
-              </a:rPr>
-              <a:t>[1] A. Sarkar et al., “Shadows Don’t Lie and Lines Can’t Bend! Generative Models don’t know Projective Geometry…for now,” CVPR, 2024.</a:t>
-            </a:r>
-          </a:p>
-          <a:p>
-            <a:pPr>
-              <a:spcAft>
-                <a:spcPts val="700"/>
-              </a:spcAft>
-            </a:pPr>
-            <a:r>
-              <a:rPr sz="1200">
-                <a:solidFill>
-                  <a:srgbClr val="1A1A1A"/>
-                </a:solidFill>
-                <a:latin typeface="Calibri"/>
-              </a:rPr>
-              <a:t>[2] R. Hartley and A. Zisserman, Multiple View Geometry in Computer Vision, 2nd ed., Cambridge University Press, 2004.</a:t>
-            </a:r>
-          </a:p>
-          <a:p>
-            <a:pPr>
-              <a:spcAft>
-                <a:spcPts val="700"/>
-              </a:spcAft>
-            </a:pPr>
-            <a:r>
-              <a:rPr sz="1200">
-                <a:solidFill>
-                  <a:srgbClr val="1A1A1A"/>
-                </a:solidFill>
-                <a:latin typeface="Calibri"/>
-              </a:rPr>
-              <a:t>[3] E. Kee, J. F. O’Brien and H. Farid, “Exposing photo manipulation with inconsistent shadows,” ACM TOG, vol. 32, no. 3, 2013.</a:t>
-            </a:r>
-          </a:p>
-          <a:p>
-            <a:pPr>
-              <a:spcAft>
-                <a:spcPts val="700"/>
-              </a:spcAft>
-            </a:pPr>
-            <a:r>
-              <a:rPr sz="1200">
-                <a:solidFill>
-                  <a:srgbClr val="1A1A1A"/>
-                </a:solidFill>
-                <a:latin typeface="Calibri"/>
-              </a:rPr>
-              <a:t>[4] A. Criminisi, I. Reid and A. Zisserman, “Single view metrology,” IJCV, vol. 40, no. 2, pp. 123–148, 2000.</a:t>
-            </a:r>
-          </a:p>
-          <a:p>
-            <a:pPr>
-              <a:spcAft>
-                <a:spcPts val="700"/>
-              </a:spcAft>
-            </a:pPr>
-            <a:r>
-              <a:rPr sz="1200">
-                <a:solidFill>
-                  <a:srgbClr val="1A1A1A"/>
-                </a:solidFill>
-                <a:latin typeface="Calibri"/>
-              </a:rPr>
-              <a:t>[5] J. M. Coughlan and A. L. Yuille, “Manhattan world,” ICCV, 1999.</a:t>
-            </a:r>
-          </a:p>
-          <a:p>
-            <a:pPr>
-              <a:spcAft>
-                <a:spcPts val="700"/>
-              </a:spcAft>
-            </a:pPr>
-            <a:r>
-              <a:rPr sz="1200">
-                <a:solidFill>
-                  <a:srgbClr val="1A1A1A"/>
-                </a:solidFill>
-                <a:latin typeface="Calibri"/>
-              </a:rPr>
-              <a:t>[6] P. Denis, J. H. Elder and F. J. Estrada, “Efficient edge-based methods for estimating Manhattan frames in urban imagery,” ECCV, 2008.</a:t>
-            </a:r>
-          </a:p>
-          <a:p>
-            <a:pPr>
-              <a:spcAft>
-                <a:spcPts val="700"/>
-              </a:spcAft>
-            </a:pPr>
-            <a:r>
-              <a:rPr sz="1200">
-                <a:solidFill>
-                  <a:srgbClr val="1A1A1A"/>
-                </a:solidFill>
-                <a:latin typeface="Calibri"/>
-              </a:rPr>
-              <a:t>[7] R. Grompone von Gioi et al., “LSD: a fast line segment detector with a false detection control,” IEEE TPAMI, vol. 32, no. 4, 2010.</a:t>
-            </a:r>
-          </a:p>
-          <a:p>
-            <a:pPr>
-              <a:spcAft>
-                <a:spcPts val="700"/>
-              </a:spcAft>
-            </a:pPr>
-            <a:r>
-              <a:rPr sz="1200">
-                <a:solidFill>
-                  <a:srgbClr val="1A1A1A"/>
-                </a:solidFill>
-                <a:latin typeface="Calibri"/>
-              </a:rPr>
-              <a:t>[8] D. Hoiem, A. A. Efros and M. Hebert, “Putting objects in perspective,” IJCV, vol. 80, no. 1, 2008.</a:t>
-            </a:r>
-          </a:p>
-          <a:p>
-            <a:pPr>
-              <a:spcAft>
-                <a:spcPts val="700"/>
-              </a:spcAft>
-            </a:pPr>
-            <a:r>
-              <a:rPr sz="1200">
-                <a:solidFill>
-                  <a:srgbClr val="1A1A1A"/>
-                </a:solidFill>
-                <a:latin typeface="Calibri"/>
-              </a:rPr>
-              <a:t>[9] L. Jin et al., “Perspective fields for single image camera calibration,” CVPR, 2023.</a:t>
-            </a:r>
-          </a:p>
-          <a:p>
-            <a:pPr>
-              <a:spcAft>
-                <a:spcPts val="700"/>
-              </a:spcAft>
-            </a:pPr>
-            <a:r>
-              <a:rPr sz="1200">
-                <a:solidFill>
-                  <a:srgbClr val="1A1A1A"/>
-                </a:solidFill>
-                <a:latin typeface="Calibri"/>
-              </a:rPr>
-              <a:t>[10] D. Podell et al., “SDXL: improving latent diffusion models for high-resolution image synthesis,” ICLR, 2024.</a:t>
-            </a:r>
-          </a:p>
-          <a:p>
-            <a:pPr>
-              <a:spcAft>
-                <a:spcPts val="700"/>
-              </a:spcAft>
-            </a:pPr>
-            <a:r>
-              <a:rPr sz="1200">
-                <a:solidFill>
-                  <a:srgbClr val="1A1A1A"/>
-                </a:solidFill>
-                <a:latin typeface="Calibri"/>
-              </a:rPr>
-              <a:t>[11] R. Rombach et al., “High-resolution image synthesis with latent diffusion models,” CVPR, 2022.</a:t>
-            </a:r>
-          </a:p>
-        </p:txBody>
-      </p:sp>
-      <p:sp>
-        <p:nvSpPr>
-          <p:cNvPr id="5" name="TextBox 4"/>
-          <p:cNvSpPr txBox="1"/>
-          <p:nvPr/>
-        </p:nvSpPr>
-        <p:spPr>
-          <a:xfrm>
-            <a:off x="640080" y="6309360"/>
-            <a:ext cx="10908792" cy="365760"/>
+            <a:off x="1389888" y="2194560"/>
+            <a:ext cx="2560320" cy="365760"/>
           </a:xfrm>
           <a:prstGeom prst="rect">
             <a:avLst/>
@@ -11222,13 +10895,892 @@
               </a:spcAft>
             </a:pPr>
             <a:r>
-              <a:rPr sz="1100" b="0" i="1">
+              <a:rPr sz="1450" b="1" i="0">
+                <a:solidFill>
+                  <a:srgbClr val="12263A"/>
+                </a:solidFill>
+                <a:latin typeface="Cambria"/>
+              </a:rPr>
+              <a:t>Frontier models</a:t>
+            </a:r>
+          </a:p>
+        </p:txBody>
+      </p:sp>
+      <p:sp>
+        <p:nvSpPr>
+          <p:cNvPr id="7" name="TextBox 6"/>
+          <p:cNvSpPr txBox="1"/>
+          <p:nvPr/>
+        </p:nvSpPr>
+        <p:spPr>
+          <a:xfrm>
+            <a:off x="914400" y="2697480"/>
+            <a:ext cx="2971800" cy="960120"/>
+          </a:xfrm>
+          <a:prstGeom prst="rect">
+            <a:avLst/>
+          </a:prstGeom>
+          <a:noFill/>
+        </p:spPr>
+        <p:txBody>
+          <a:bodyPr wrap="square" lIns="0" rIns="0" tIns="0" bIns="0" anchor="t">
+            <a:spAutoFit/>
+          </a:bodyPr>
+          <a:lstStyle/>
+          <a:p>
+            <a:pPr algn="l">
+              <a:spcAft>
+                <a:spcPts val="600"/>
+              </a:spcAft>
+            </a:pPr>
+            <a:r>
+              <a:rPr sz="1200" b="0" i="0">
                 <a:solidFill>
                   <a:srgbClr val="5A6672"/>
                 </a:solidFill>
                 <a:latin typeface="Calibri"/>
               </a:rPr>
-              <a:t>Dataset credits: York Urban Database (Elder Laboratory, York University); Wikimedia Commons photographs under CC licences, per-image attribution in the project metadata.</a:t>
+              <a:t>Gemini, GPT-image and FLUX on the same prompt set. Slot reserved on the Results 6 slide; prompts already exported.</a:t>
+            </a:r>
+          </a:p>
+        </p:txBody>
+      </p:sp>
+      <p:sp>
+        <p:nvSpPr>
+          <p:cNvPr id="8" name="Rounded Rectangle 7"/>
+          <p:cNvSpPr/>
+          <p:nvPr/>
+        </p:nvSpPr>
+        <p:spPr>
+          <a:xfrm>
+            <a:off x="4407408" y="1920240"/>
+            <a:ext cx="3520440" cy="1874519"/>
+          </a:xfrm>
+          <a:prstGeom prst="roundRect">
+            <a:avLst>
+              <a:gd name="adj" fmla="val 6000"/>
+            </a:avLst>
+          </a:prstGeom>
+          <a:solidFill>
+            <a:srgbClr val="F4F6F8"/>
+          </a:solidFill>
+          <a:ln>
+            <a:noFill/>
+          </a:ln>
+          <a:effectLst/>
+        </p:spPr>
+        <p:style>
+          <a:lnRef idx="1">
+            <a:schemeClr val="accent1"/>
+          </a:lnRef>
+          <a:fillRef idx="3">
+            <a:schemeClr val="accent1"/>
+          </a:fillRef>
+          <a:effectRef idx="2">
+            <a:schemeClr val="accent1"/>
+          </a:effectRef>
+          <a:fontRef idx="minor">
+            <a:schemeClr val="lt1"/>
+          </a:fontRef>
+        </p:style>
+        <p:txBody>
+          <a:bodyPr rtlCol="0" anchor="ctr"/>
+          <a:lstStyle/>
+          <a:p>
+            <a:pPr algn="ctr"/>
+          </a:p>
+        </p:txBody>
+      </p:sp>
+      <p:sp>
+        <p:nvSpPr>
+          <p:cNvPr id="9" name="Oval 8"/>
+          <p:cNvSpPr/>
+          <p:nvPr/>
+        </p:nvSpPr>
+        <p:spPr>
+          <a:xfrm>
+            <a:off x="4681728" y="2176272"/>
+            <a:ext cx="329184" cy="329184"/>
+          </a:xfrm>
+          <a:prstGeom prst="ellipse">
+            <a:avLst/>
+          </a:prstGeom>
+          <a:solidFill>
+            <a:srgbClr val="12263A"/>
+          </a:solidFill>
+          <a:ln>
+            <a:noFill/>
+          </a:ln>
+          <a:effectLst/>
+        </p:spPr>
+        <p:style>
+          <a:lnRef idx="1">
+            <a:schemeClr val="accent1"/>
+          </a:lnRef>
+          <a:fillRef idx="3">
+            <a:schemeClr val="accent1"/>
+          </a:fillRef>
+          <a:effectRef idx="2">
+            <a:schemeClr val="accent1"/>
+          </a:effectRef>
+          <a:fontRef idx="minor">
+            <a:schemeClr val="lt1"/>
+          </a:fontRef>
+        </p:style>
+        <p:txBody>
+          <a:bodyPr rtlCol="0" anchor="ctr"/>
+          <a:lstStyle/>
+          <a:p>
+            <a:pPr algn="ctr"/>
+          </a:p>
+        </p:txBody>
+      </p:sp>
+      <p:sp>
+        <p:nvSpPr>
+          <p:cNvPr id="10" name="TextBox 9"/>
+          <p:cNvSpPr txBox="1"/>
+          <p:nvPr/>
+        </p:nvSpPr>
+        <p:spPr>
+          <a:xfrm>
+            <a:off x="5157216" y="2194560"/>
+            <a:ext cx="2560320" cy="365760"/>
+          </a:xfrm>
+          <a:prstGeom prst="rect">
+            <a:avLst/>
+          </a:prstGeom>
+          <a:noFill/>
+        </p:spPr>
+        <p:txBody>
+          <a:bodyPr wrap="square" lIns="0" rIns="0" tIns="0" bIns="0" anchor="t">
+            <a:spAutoFit/>
+          </a:bodyPr>
+          <a:lstStyle/>
+          <a:p>
+            <a:pPr algn="l">
+              <a:spcAft>
+                <a:spcPts val="600"/>
+              </a:spcAft>
+            </a:pPr>
+            <a:r>
+              <a:rPr sz="1450" b="1" i="0">
+                <a:solidFill>
+                  <a:srgbClr val="12263A"/>
+                </a:solidFill>
+                <a:latin typeface="Cambria"/>
+              </a:rPr>
+              <a:t>Shadow association</a:t>
+            </a:r>
+          </a:p>
+        </p:txBody>
+      </p:sp>
+      <p:sp>
+        <p:nvSpPr>
+          <p:cNvPr id="11" name="TextBox 10"/>
+          <p:cNvSpPr txBox="1"/>
+          <p:nvPr/>
+        </p:nvSpPr>
+        <p:spPr>
+          <a:xfrm>
+            <a:off x="4681728" y="2697480"/>
+            <a:ext cx="2971800" cy="960120"/>
+          </a:xfrm>
+          <a:prstGeom prst="rect">
+            <a:avLst/>
+          </a:prstGeom>
+          <a:noFill/>
+        </p:spPr>
+        <p:txBody>
+          <a:bodyPr wrap="square" lIns="0" rIns="0" tIns="0" bIns="0" anchor="t">
+            <a:spAutoFit/>
+          </a:bodyPr>
+          <a:lstStyle/>
+          <a:p>
+            <a:pPr algn="l">
+              <a:spcAft>
+                <a:spcPts val="600"/>
+              </a:spcAft>
+            </a:pPr>
+            <a:r>
+              <a:rPr sz="1200" b="0" i="0">
+                <a:solidFill>
+                  <a:srgbClr val="5A6672"/>
+                </a:solidFill>
+                <a:latin typeface="Calibri"/>
+              </a:rPr>
+              <a:t>SSIS or SAM 2 for object-shadow pairs; the wedge LP above it is built and validated.</a:t>
+            </a:r>
+          </a:p>
+        </p:txBody>
+      </p:sp>
+      <p:sp>
+        <p:nvSpPr>
+          <p:cNvPr id="12" name="Rounded Rectangle 11"/>
+          <p:cNvSpPr/>
+          <p:nvPr/>
+        </p:nvSpPr>
+        <p:spPr>
+          <a:xfrm>
+            <a:off x="8174736" y="1920240"/>
+            <a:ext cx="3520440" cy="1874519"/>
+          </a:xfrm>
+          <a:prstGeom prst="roundRect">
+            <a:avLst>
+              <a:gd name="adj" fmla="val 6000"/>
+            </a:avLst>
+          </a:prstGeom>
+          <a:solidFill>
+            <a:srgbClr val="F4F6F8"/>
+          </a:solidFill>
+          <a:ln>
+            <a:noFill/>
+          </a:ln>
+          <a:effectLst/>
+        </p:spPr>
+        <p:style>
+          <a:lnRef idx="1">
+            <a:schemeClr val="accent1"/>
+          </a:lnRef>
+          <a:fillRef idx="3">
+            <a:schemeClr val="accent1"/>
+          </a:fillRef>
+          <a:effectRef idx="2">
+            <a:schemeClr val="accent1"/>
+          </a:effectRef>
+          <a:fontRef idx="minor">
+            <a:schemeClr val="lt1"/>
+          </a:fontRef>
+        </p:style>
+        <p:txBody>
+          <a:bodyPr rtlCol="0" anchor="ctr"/>
+          <a:lstStyle/>
+          <a:p>
+            <a:pPr algn="ctr"/>
+          </a:p>
+        </p:txBody>
+      </p:sp>
+      <p:sp>
+        <p:nvSpPr>
+          <p:cNvPr id="13" name="Oval 12"/>
+          <p:cNvSpPr/>
+          <p:nvPr/>
+        </p:nvSpPr>
+        <p:spPr>
+          <a:xfrm>
+            <a:off x="8449056" y="2176272"/>
+            <a:ext cx="329184" cy="329184"/>
+          </a:xfrm>
+          <a:prstGeom prst="ellipse">
+            <a:avLst/>
+          </a:prstGeom>
+          <a:solidFill>
+            <a:srgbClr val="1C7293"/>
+          </a:solidFill>
+          <a:ln>
+            <a:noFill/>
+          </a:ln>
+          <a:effectLst/>
+        </p:spPr>
+        <p:style>
+          <a:lnRef idx="1">
+            <a:schemeClr val="accent1"/>
+          </a:lnRef>
+          <a:fillRef idx="3">
+            <a:schemeClr val="accent1"/>
+          </a:fillRef>
+          <a:effectRef idx="2">
+            <a:schemeClr val="accent1"/>
+          </a:effectRef>
+          <a:fontRef idx="minor">
+            <a:schemeClr val="lt1"/>
+          </a:fontRef>
+        </p:style>
+        <p:txBody>
+          <a:bodyPr rtlCol="0" anchor="ctr"/>
+          <a:lstStyle/>
+          <a:p>
+            <a:pPr algn="ctr"/>
+          </a:p>
+        </p:txBody>
+      </p:sp>
+      <p:sp>
+        <p:nvSpPr>
+          <p:cNvPr id="14" name="TextBox 13"/>
+          <p:cNvSpPr txBox="1"/>
+          <p:nvPr/>
+        </p:nvSpPr>
+        <p:spPr>
+          <a:xfrm>
+            <a:off x="8924544" y="2194560"/>
+            <a:ext cx="2560320" cy="365760"/>
+          </a:xfrm>
+          <a:prstGeom prst="rect">
+            <a:avLst/>
+          </a:prstGeom>
+          <a:noFill/>
+        </p:spPr>
+        <p:txBody>
+          <a:bodyPr wrap="square" lIns="0" rIns="0" tIns="0" bIns="0" anchor="t">
+            <a:spAutoFit/>
+          </a:bodyPr>
+          <a:lstStyle/>
+          <a:p>
+            <a:pPr algn="l">
+              <a:spcAft>
+                <a:spcPts val="600"/>
+              </a:spcAft>
+            </a:pPr>
+            <a:r>
+              <a:rPr sz="1450" b="1" i="0">
+                <a:solidFill>
+                  <a:srgbClr val="12263A"/>
+                </a:solidFill>
+                <a:latin typeface="Cambria"/>
+              </a:rPr>
+              <a:t>Remaining levels</a:t>
+            </a:r>
+          </a:p>
+        </p:txBody>
+      </p:sp>
+      <p:sp>
+        <p:nvSpPr>
+          <p:cNvPr id="15" name="TextBox 14"/>
+          <p:cNvSpPr txBox="1"/>
+          <p:nvPr/>
+        </p:nvSpPr>
+        <p:spPr>
+          <a:xfrm>
+            <a:off x="8449056" y="2697480"/>
+            <a:ext cx="2971800" cy="960120"/>
+          </a:xfrm>
+          <a:prstGeom prst="rect">
+            <a:avLst/>
+          </a:prstGeom>
+          <a:noFill/>
+        </p:spPr>
+        <p:txBody>
+          <a:bodyPr wrap="square" lIns="0" rIns="0" tIns="0" bIns="0" anchor="t">
+            <a:spAutoFit/>
+          </a:bodyPr>
+          <a:lstStyle/>
+          <a:p>
+            <a:pPr algn="l">
+              <a:spcAft>
+                <a:spcPts val="600"/>
+              </a:spcAft>
+            </a:pPr>
+            <a:r>
+              <a:rPr sz="1200" b="0" i="0">
+                <a:solidFill>
+                  <a:srgbClr val="5A6672"/>
+                </a:solidFill>
+                <a:latin typeface="Calibri"/>
+              </a:rPr>
+              <a:t>Cross-ratio, conics, reflections and cross-modal normal agreement.</a:t>
+            </a:r>
+          </a:p>
+        </p:txBody>
+      </p:sp>
+      <p:sp>
+        <p:nvSpPr>
+          <p:cNvPr id="16" name="Rounded Rectangle 15"/>
+          <p:cNvSpPr/>
+          <p:nvPr/>
+        </p:nvSpPr>
+        <p:spPr>
+          <a:xfrm>
+            <a:off x="640080" y="4114800"/>
+            <a:ext cx="3520440" cy="1874519"/>
+          </a:xfrm>
+          <a:prstGeom prst="roundRect">
+            <a:avLst>
+              <a:gd name="adj" fmla="val 6000"/>
+            </a:avLst>
+          </a:prstGeom>
+          <a:solidFill>
+            <a:srgbClr val="F4F6F8"/>
+          </a:solidFill>
+          <a:ln>
+            <a:noFill/>
+          </a:ln>
+          <a:effectLst/>
+        </p:spPr>
+        <p:style>
+          <a:lnRef idx="1">
+            <a:schemeClr val="accent1"/>
+          </a:lnRef>
+          <a:fillRef idx="3">
+            <a:schemeClr val="accent1"/>
+          </a:fillRef>
+          <a:effectRef idx="2">
+            <a:schemeClr val="accent1"/>
+          </a:effectRef>
+          <a:fontRef idx="minor">
+            <a:schemeClr val="lt1"/>
+          </a:fontRef>
+        </p:style>
+        <p:txBody>
+          <a:bodyPr rtlCol="0" anchor="ctr"/>
+          <a:lstStyle/>
+          <a:p>
+            <a:pPr algn="ctr"/>
+          </a:p>
+        </p:txBody>
+      </p:sp>
+      <p:sp>
+        <p:nvSpPr>
+          <p:cNvPr id="17" name="Oval 16"/>
+          <p:cNvSpPr/>
+          <p:nvPr/>
+        </p:nvSpPr>
+        <p:spPr>
+          <a:xfrm>
+            <a:off x="914400" y="4370832"/>
+            <a:ext cx="329184" cy="329184"/>
+          </a:xfrm>
+          <a:prstGeom prst="ellipse">
+            <a:avLst/>
+          </a:prstGeom>
+          <a:solidFill>
+            <a:srgbClr val="E8A33D"/>
+          </a:solidFill>
+          <a:ln>
+            <a:noFill/>
+          </a:ln>
+          <a:effectLst/>
+        </p:spPr>
+        <p:style>
+          <a:lnRef idx="1">
+            <a:schemeClr val="accent1"/>
+          </a:lnRef>
+          <a:fillRef idx="3">
+            <a:schemeClr val="accent1"/>
+          </a:fillRef>
+          <a:effectRef idx="2">
+            <a:schemeClr val="accent1"/>
+          </a:effectRef>
+          <a:fontRef idx="minor">
+            <a:schemeClr val="lt1"/>
+          </a:fontRef>
+        </p:style>
+        <p:txBody>
+          <a:bodyPr rtlCol="0" anchor="ctr"/>
+          <a:lstStyle/>
+          <a:p>
+            <a:pPr algn="ctr"/>
+          </a:p>
+        </p:txBody>
+      </p:sp>
+      <p:sp>
+        <p:nvSpPr>
+          <p:cNvPr id="18" name="TextBox 17"/>
+          <p:cNvSpPr txBox="1"/>
+          <p:nvPr/>
+        </p:nvSpPr>
+        <p:spPr>
+          <a:xfrm>
+            <a:off x="1389888" y="4389120"/>
+            <a:ext cx="2560320" cy="365760"/>
+          </a:xfrm>
+          <a:prstGeom prst="rect">
+            <a:avLst/>
+          </a:prstGeom>
+          <a:noFill/>
+        </p:spPr>
+        <p:txBody>
+          <a:bodyPr wrap="square" lIns="0" rIns="0" tIns="0" bIns="0" anchor="t">
+            <a:spAutoFit/>
+          </a:bodyPr>
+          <a:lstStyle/>
+          <a:p>
+            <a:pPr algn="l">
+              <a:spcAft>
+                <a:spcPts val="600"/>
+              </a:spcAft>
+            </a:pPr>
+            <a:r>
+              <a:rPr sz="1450" b="1" i="0">
+                <a:solidFill>
+                  <a:srgbClr val="12263A"/>
+                </a:solidFill>
+                <a:latin typeface="Cambria"/>
+              </a:rPr>
+              <a:t>Mechanism</a:t>
+            </a:r>
+          </a:p>
+        </p:txBody>
+      </p:sp>
+      <p:sp>
+        <p:nvSpPr>
+          <p:cNvPr id="19" name="TextBox 18"/>
+          <p:cNvSpPr txBox="1"/>
+          <p:nvPr/>
+        </p:nvSpPr>
+        <p:spPr>
+          <a:xfrm>
+            <a:off x="914400" y="4892040"/>
+            <a:ext cx="2971800" cy="960120"/>
+          </a:xfrm>
+          <a:prstGeom prst="rect">
+            <a:avLst/>
+          </a:prstGeom>
+          <a:noFill/>
+        </p:spPr>
+        <p:txBody>
+          <a:bodyPr wrap="square" lIns="0" rIns="0" tIns="0" bIns="0" anchor="t">
+            <a:spAutoFit/>
+          </a:bodyPr>
+          <a:lstStyle/>
+          <a:p>
+            <a:pPr algn="l">
+              <a:spcAft>
+                <a:spcPts val="600"/>
+              </a:spcAft>
+            </a:pPr>
+            <a:r>
+              <a:rPr sz="1200" b="0" i="0">
+                <a:solidFill>
+                  <a:srgbClr val="5A6672"/>
+                </a:solidFill>
+                <a:latin typeface="Calibri"/>
+              </a:rPr>
+              <a:t>Why does scale not fix camera coherence? Aspect ratio is ruled out; resolution and latent receptive field remain.</a:t>
+            </a:r>
+          </a:p>
+        </p:txBody>
+      </p:sp>
+      <p:sp>
+        <p:nvSpPr>
+          <p:cNvPr id="20" name="Rounded Rectangle 19"/>
+          <p:cNvSpPr/>
+          <p:nvPr/>
+        </p:nvSpPr>
+        <p:spPr>
+          <a:xfrm>
+            <a:off x="4407408" y="4114800"/>
+            <a:ext cx="3520440" cy="1874519"/>
+          </a:xfrm>
+          <a:prstGeom prst="roundRect">
+            <a:avLst>
+              <a:gd name="adj" fmla="val 6000"/>
+            </a:avLst>
+          </a:prstGeom>
+          <a:solidFill>
+            <a:srgbClr val="F4F6F8"/>
+          </a:solidFill>
+          <a:ln>
+            <a:noFill/>
+          </a:ln>
+          <a:effectLst/>
+        </p:spPr>
+        <p:style>
+          <a:lnRef idx="1">
+            <a:schemeClr val="accent1"/>
+          </a:lnRef>
+          <a:fillRef idx="3">
+            <a:schemeClr val="accent1"/>
+          </a:fillRef>
+          <a:effectRef idx="2">
+            <a:schemeClr val="accent1"/>
+          </a:effectRef>
+          <a:fontRef idx="minor">
+            <a:schemeClr val="lt1"/>
+          </a:fontRef>
+        </p:style>
+        <p:txBody>
+          <a:bodyPr rtlCol="0" anchor="ctr"/>
+          <a:lstStyle/>
+          <a:p>
+            <a:pPr algn="ctr"/>
+          </a:p>
+        </p:txBody>
+      </p:sp>
+      <p:sp>
+        <p:nvSpPr>
+          <p:cNvPr id="21" name="Oval 20"/>
+          <p:cNvSpPr/>
+          <p:nvPr/>
+        </p:nvSpPr>
+        <p:spPr>
+          <a:xfrm>
+            <a:off x="4681728" y="4370832"/>
+            <a:ext cx="329184" cy="329184"/>
+          </a:xfrm>
+          <a:prstGeom prst="ellipse">
+            <a:avLst/>
+          </a:prstGeom>
+          <a:solidFill>
+            <a:srgbClr val="12263A"/>
+          </a:solidFill>
+          <a:ln>
+            <a:noFill/>
+          </a:ln>
+          <a:effectLst/>
+        </p:spPr>
+        <p:style>
+          <a:lnRef idx="1">
+            <a:schemeClr val="accent1"/>
+          </a:lnRef>
+          <a:fillRef idx="3">
+            <a:schemeClr val="accent1"/>
+          </a:fillRef>
+          <a:effectRef idx="2">
+            <a:schemeClr val="accent1"/>
+          </a:effectRef>
+          <a:fontRef idx="minor">
+            <a:schemeClr val="lt1"/>
+          </a:fontRef>
+        </p:style>
+        <p:txBody>
+          <a:bodyPr rtlCol="0" anchor="ctr"/>
+          <a:lstStyle/>
+          <a:p>
+            <a:pPr algn="ctr"/>
+          </a:p>
+        </p:txBody>
+      </p:sp>
+      <p:sp>
+        <p:nvSpPr>
+          <p:cNvPr id="22" name="TextBox 21"/>
+          <p:cNvSpPr txBox="1"/>
+          <p:nvPr/>
+        </p:nvSpPr>
+        <p:spPr>
+          <a:xfrm>
+            <a:off x="5157216" y="4389120"/>
+            <a:ext cx="2560320" cy="365760"/>
+          </a:xfrm>
+          <a:prstGeom prst="rect">
+            <a:avLst/>
+          </a:prstGeom>
+          <a:noFill/>
+        </p:spPr>
+        <p:txBody>
+          <a:bodyPr wrap="square" lIns="0" rIns="0" tIns="0" bIns="0" anchor="t">
+            <a:spAutoFit/>
+          </a:bodyPr>
+          <a:lstStyle/>
+          <a:p>
+            <a:pPr algn="l">
+              <a:spcAft>
+                <a:spcPts val="600"/>
+              </a:spcAft>
+            </a:pPr>
+            <a:r>
+              <a:rPr sz="1450" b="1" i="0">
+                <a:solidFill>
+                  <a:srgbClr val="12263A"/>
+                </a:solidFill>
+                <a:latin typeface="Cambria"/>
+              </a:rPr>
+              <a:t>Sheaf formalism</a:t>
+            </a:r>
+          </a:p>
+        </p:txBody>
+      </p:sp>
+      <p:sp>
+        <p:nvSpPr>
+          <p:cNvPr id="23" name="TextBox 22"/>
+          <p:cNvSpPr txBox="1"/>
+          <p:nvPr/>
+        </p:nvSpPr>
+        <p:spPr>
+          <a:xfrm>
+            <a:off x="4681728" y="4892040"/>
+            <a:ext cx="2971800" cy="960120"/>
+          </a:xfrm>
+          <a:prstGeom prst="rect">
+            <a:avLst/>
+          </a:prstGeom>
+          <a:noFill/>
+        </p:spPr>
+        <p:txBody>
+          <a:bodyPr wrap="square" lIns="0" rIns="0" tIns="0" bIns="0" anchor="t">
+            <a:spAutoFit/>
+          </a:bodyPr>
+          <a:lstStyle/>
+          <a:p>
+            <a:pPr algn="l">
+              <a:spcAft>
+                <a:spcPts val="600"/>
+              </a:spcAft>
+            </a:pPr>
+            <a:r>
+              <a:rPr sz="1200" b="0" i="0">
+                <a:solidFill>
+                  <a:srgbClr val="5A6672"/>
+                </a:solidFill>
+                <a:latin typeface="Calibri"/>
+              </a:rPr>
+              <a:t>Consistency radius over a cover of local cameras as a principled local-to-global measure.</a:t>
+            </a:r>
+          </a:p>
+        </p:txBody>
+      </p:sp>
+      <p:sp>
+        <p:nvSpPr>
+          <p:cNvPr id="24" name="Rounded Rectangle 23"/>
+          <p:cNvSpPr/>
+          <p:nvPr/>
+        </p:nvSpPr>
+        <p:spPr>
+          <a:xfrm>
+            <a:off x="8174736" y="4114800"/>
+            <a:ext cx="3520440" cy="1874519"/>
+          </a:xfrm>
+          <a:prstGeom prst="roundRect">
+            <a:avLst>
+              <a:gd name="adj" fmla="val 6000"/>
+            </a:avLst>
+          </a:prstGeom>
+          <a:solidFill>
+            <a:srgbClr val="F4F6F8"/>
+          </a:solidFill>
+          <a:ln>
+            <a:noFill/>
+          </a:ln>
+          <a:effectLst/>
+        </p:spPr>
+        <p:style>
+          <a:lnRef idx="1">
+            <a:schemeClr val="accent1"/>
+          </a:lnRef>
+          <a:fillRef idx="3">
+            <a:schemeClr val="accent1"/>
+          </a:fillRef>
+          <a:effectRef idx="2">
+            <a:schemeClr val="accent1"/>
+          </a:effectRef>
+          <a:fontRef idx="minor">
+            <a:schemeClr val="lt1"/>
+          </a:fontRef>
+        </p:style>
+        <p:txBody>
+          <a:bodyPr rtlCol="0" anchor="ctr"/>
+          <a:lstStyle/>
+          <a:p>
+            <a:pPr algn="ctr"/>
+          </a:p>
+        </p:txBody>
+      </p:sp>
+      <p:sp>
+        <p:nvSpPr>
+          <p:cNvPr id="25" name="Oval 24"/>
+          <p:cNvSpPr/>
+          <p:nvPr/>
+        </p:nvSpPr>
+        <p:spPr>
+          <a:xfrm>
+            <a:off x="8449056" y="4370832"/>
+            <a:ext cx="329184" cy="329184"/>
+          </a:xfrm>
+          <a:prstGeom prst="ellipse">
+            <a:avLst/>
+          </a:prstGeom>
+          <a:solidFill>
+            <a:srgbClr val="1C7293"/>
+          </a:solidFill>
+          <a:ln>
+            <a:noFill/>
+          </a:ln>
+          <a:effectLst/>
+        </p:spPr>
+        <p:style>
+          <a:lnRef idx="1">
+            <a:schemeClr val="accent1"/>
+          </a:lnRef>
+          <a:fillRef idx="3">
+            <a:schemeClr val="accent1"/>
+          </a:fillRef>
+          <a:effectRef idx="2">
+            <a:schemeClr val="accent1"/>
+          </a:effectRef>
+          <a:fontRef idx="minor">
+            <a:schemeClr val="lt1"/>
+          </a:fontRef>
+        </p:style>
+        <p:txBody>
+          <a:bodyPr rtlCol="0" anchor="ctr"/>
+          <a:lstStyle/>
+          <a:p>
+            <a:pPr algn="ctr"/>
+          </a:p>
+        </p:txBody>
+      </p:sp>
+      <p:sp>
+        <p:nvSpPr>
+          <p:cNvPr id="26" name="TextBox 25"/>
+          <p:cNvSpPr txBox="1"/>
+          <p:nvPr/>
+        </p:nvSpPr>
+        <p:spPr>
+          <a:xfrm>
+            <a:off x="8924544" y="4389120"/>
+            <a:ext cx="2560320" cy="365760"/>
+          </a:xfrm>
+          <a:prstGeom prst="rect">
+            <a:avLst/>
+          </a:prstGeom>
+          <a:noFill/>
+        </p:spPr>
+        <p:txBody>
+          <a:bodyPr wrap="square" lIns="0" rIns="0" tIns="0" bIns="0" anchor="t">
+            <a:spAutoFit/>
+          </a:bodyPr>
+          <a:lstStyle/>
+          <a:p>
+            <a:pPr algn="l">
+              <a:spcAft>
+                <a:spcPts val="600"/>
+              </a:spcAft>
+            </a:pPr>
+            <a:r>
+              <a:rPr sz="1450" b="1" i="0">
+                <a:solidFill>
+                  <a:srgbClr val="12263A"/>
+                </a:solidFill>
+                <a:latin typeface="Cambria"/>
+              </a:rPr>
+              <a:t>Perception study</a:t>
+            </a:r>
+          </a:p>
+        </p:txBody>
+      </p:sp>
+      <p:sp>
+        <p:nvSpPr>
+          <p:cNvPr id="27" name="TextBox 26"/>
+          <p:cNvSpPr txBox="1"/>
+          <p:nvPr/>
+        </p:nvSpPr>
+        <p:spPr>
+          <a:xfrm>
+            <a:off x="8449056" y="4892040"/>
+            <a:ext cx="2971800" cy="960120"/>
+          </a:xfrm>
+          <a:prstGeom prst="rect">
+            <a:avLst/>
+          </a:prstGeom>
+          <a:noFill/>
+        </p:spPr>
+        <p:txBody>
+          <a:bodyPr wrap="square" lIns="0" rIns="0" tIns="0" bIns="0" anchor="t">
+            <a:spAutoFit/>
+          </a:bodyPr>
+          <a:lstStyle/>
+          <a:p>
+            <a:pPr algn="l">
+              <a:spcAft>
+                <a:spcPts val="600"/>
+              </a:spcAft>
+            </a:pPr>
+            <a:r>
+              <a:rPr sz="1200" b="0" i="0">
+                <a:solidFill>
+                  <a:srgbClr val="5A6672"/>
+                </a:solidFill>
+                <a:latin typeface="Calibri"/>
+              </a:rPr>
+              <a:t>Which violations are mathematically severe but visually unnoticed.</a:t>
             </a:r>
           </a:p>
         </p:txBody>
@@ -11706,6 +12258,345 @@
                 <a:latin typeface="Calibri"/>
               </a:rPr>
               <a:t>No real camera can break these.</a:t>
+            </a:r>
+          </a:p>
+        </p:txBody>
+      </p:sp>
+    </p:spTree>
+  </p:cSld>
+  <p:clrMapOvr>
+    <a:masterClrMapping/>
+  </p:clrMapOvr>
+</p:sld>
+</file>
+
+<file path=ppt/slides/slide20.xml><?xml version="1.0" encoding="utf-8"?>
+<p:sld xmlns:a="http://schemas.openxmlformats.org/drawingml/2006/main" xmlns:p="http://schemas.openxmlformats.org/presentationml/2006/main" xmlns:r="http://schemas.openxmlformats.org/officeDocument/2006/relationships">
+  <p:cSld>
+    <p:spTree>
+      <p:nvGrpSpPr>
+        <p:cNvPr id="1" name=""/>
+        <p:cNvGrpSpPr/>
+        <p:nvPr/>
+      </p:nvGrpSpPr>
+      <p:grpSpPr/>
+      <p:sp>
+        <p:nvSpPr>
+          <p:cNvPr id="2" name="Rectangle 1"/>
+          <p:cNvSpPr/>
+          <p:nvPr/>
+        </p:nvSpPr>
+        <p:spPr>
+          <a:xfrm>
+            <a:off x="0" y="0"/>
+            <a:ext cx="12191695" cy="6858000"/>
+          </a:xfrm>
+          <a:prstGeom prst="rect">
+            <a:avLst/>
+          </a:prstGeom>
+          <a:solidFill>
+            <a:srgbClr val="FFFFFF"/>
+          </a:solidFill>
+          <a:ln>
+            <a:noFill/>
+          </a:ln>
+          <a:effectLst/>
+        </p:spPr>
+        <p:style>
+          <a:lnRef idx="1">
+            <a:schemeClr val="accent1"/>
+          </a:lnRef>
+          <a:fillRef idx="3">
+            <a:schemeClr val="accent1"/>
+          </a:fillRef>
+          <a:effectRef idx="2">
+            <a:schemeClr val="accent1"/>
+          </a:effectRef>
+          <a:fontRef idx="minor">
+            <a:schemeClr val="lt1"/>
+          </a:fontRef>
+        </p:style>
+        <p:txBody>
+          <a:bodyPr rtlCol="0" anchor="ctr"/>
+          <a:lstStyle/>
+          <a:p>
+            <a:pPr algn="ctr"/>
+          </a:p>
+        </p:txBody>
+      </p:sp>
+      <p:sp>
+        <p:nvSpPr>
+          <p:cNvPr id="3" name="TextBox 2"/>
+          <p:cNvSpPr txBox="1"/>
+          <p:nvPr/>
+        </p:nvSpPr>
+        <p:spPr>
+          <a:xfrm>
+            <a:off x="640080" y="457200"/>
+            <a:ext cx="10911535" cy="822960"/>
+          </a:xfrm>
+          <a:prstGeom prst="rect">
+            <a:avLst/>
+          </a:prstGeom>
+          <a:noFill/>
+        </p:spPr>
+        <p:txBody>
+          <a:bodyPr wrap="square" lIns="0" rIns="0" tIns="0" bIns="0" anchor="t">
+            <a:spAutoFit/>
+          </a:bodyPr>
+          <a:lstStyle/>
+          <a:p>
+            <a:pPr algn="l">
+              <a:spcAft>
+                <a:spcPts val="600"/>
+              </a:spcAft>
+            </a:pPr>
+            <a:r>
+              <a:rPr sz="3200" b="1" i="0">
+                <a:solidFill>
+                  <a:srgbClr val="12263A"/>
+                </a:solidFill>
+                <a:latin typeface="Cambria"/>
+              </a:rPr>
+              <a:t>References</a:t>
+            </a:r>
+          </a:p>
+        </p:txBody>
+      </p:sp>
+      <p:sp>
+        <p:nvSpPr>
+          <p:cNvPr id="4" name="TextBox 3"/>
+          <p:cNvSpPr txBox="1"/>
+          <p:nvPr/>
+        </p:nvSpPr>
+        <p:spPr>
+          <a:xfrm>
+            <a:off x="640080" y="1783080"/>
+            <a:ext cx="10908792" cy="4480560"/>
+          </a:xfrm>
+          <a:prstGeom prst="rect">
+            <a:avLst/>
+          </a:prstGeom>
+          <a:noFill/>
+        </p:spPr>
+        <p:txBody>
+          <a:bodyPr wrap="square" lIns="0" rIns="0">
+            <a:spAutoFit/>
+          </a:bodyPr>
+          <a:lstStyle/>
+          <a:p>
+            <a:pPr>
+              <a:spcAft>
+                <a:spcPts val="700"/>
+              </a:spcAft>
+            </a:pPr>
+            <a:r>
+              <a:rPr sz="1200">
+                <a:solidFill>
+                  <a:srgbClr val="1A1A1A"/>
+                </a:solidFill>
+                <a:latin typeface="Calibri"/>
+              </a:rPr>
+              <a:t>[1] A. Sarkar et al., “Shadows Don’t Lie and Lines Can’t Bend! Generative Models don’t know Projective Geometry…for now,” CVPR, 2024.</a:t>
+            </a:r>
+          </a:p>
+          <a:p>
+            <a:pPr>
+              <a:spcAft>
+                <a:spcPts val="700"/>
+              </a:spcAft>
+            </a:pPr>
+            <a:r>
+              <a:rPr sz="1200">
+                <a:solidFill>
+                  <a:srgbClr val="1A1A1A"/>
+                </a:solidFill>
+                <a:latin typeface="Calibri"/>
+              </a:rPr>
+              <a:t>[2] R. Hartley and A. Zisserman, Multiple View Geometry in Computer Vision, 2nd ed., Cambridge University Press, 2004.</a:t>
+            </a:r>
+          </a:p>
+          <a:p>
+            <a:pPr>
+              <a:spcAft>
+                <a:spcPts val="700"/>
+              </a:spcAft>
+            </a:pPr>
+            <a:r>
+              <a:rPr sz="1200">
+                <a:solidFill>
+                  <a:srgbClr val="1A1A1A"/>
+                </a:solidFill>
+                <a:latin typeface="Calibri"/>
+              </a:rPr>
+              <a:t>[3] E. Kee, J. F. O’Brien and H. Farid, “Exposing photo manipulation with inconsistent shadows,” ACM TOG, vol. 32, no. 3, 2013.</a:t>
+            </a:r>
+          </a:p>
+          <a:p>
+            <a:pPr>
+              <a:spcAft>
+                <a:spcPts val="700"/>
+              </a:spcAft>
+            </a:pPr>
+            <a:r>
+              <a:rPr sz="1200">
+                <a:solidFill>
+                  <a:srgbClr val="1A1A1A"/>
+                </a:solidFill>
+                <a:latin typeface="Calibri"/>
+              </a:rPr>
+              <a:t>[4] A. Criminisi, I. Reid and A. Zisserman, “Single view metrology,” IJCV, vol. 40, no. 2, pp. 123–148, 2000.</a:t>
+            </a:r>
+          </a:p>
+          <a:p>
+            <a:pPr>
+              <a:spcAft>
+                <a:spcPts val="700"/>
+              </a:spcAft>
+            </a:pPr>
+            <a:r>
+              <a:rPr sz="1200">
+                <a:solidFill>
+                  <a:srgbClr val="1A1A1A"/>
+                </a:solidFill>
+                <a:latin typeface="Calibri"/>
+              </a:rPr>
+              <a:t>[5] J. M. Coughlan and A. L. Yuille, “Manhattan world,” ICCV, 1999.</a:t>
+            </a:r>
+          </a:p>
+          <a:p>
+            <a:pPr>
+              <a:spcAft>
+                <a:spcPts val="700"/>
+              </a:spcAft>
+            </a:pPr>
+            <a:r>
+              <a:rPr sz="1200">
+                <a:solidFill>
+                  <a:srgbClr val="1A1A1A"/>
+                </a:solidFill>
+                <a:latin typeface="Calibri"/>
+              </a:rPr>
+              <a:t>[6] P. Denis, J. H. Elder and F. J. Estrada, “Efficient edge-based methods for estimating Manhattan frames in urban imagery,” ECCV, 2008.</a:t>
+            </a:r>
+          </a:p>
+          <a:p>
+            <a:pPr>
+              <a:spcAft>
+                <a:spcPts val="700"/>
+              </a:spcAft>
+            </a:pPr>
+            <a:r>
+              <a:rPr sz="1200">
+                <a:solidFill>
+                  <a:srgbClr val="1A1A1A"/>
+                </a:solidFill>
+                <a:latin typeface="Calibri"/>
+              </a:rPr>
+              <a:t>[7] R. Grompone von Gioi et al., “LSD: a fast line segment detector with a false detection control,” IEEE TPAMI, vol. 32, no. 4, 2010.</a:t>
+            </a:r>
+          </a:p>
+          <a:p>
+            <a:pPr>
+              <a:spcAft>
+                <a:spcPts val="700"/>
+              </a:spcAft>
+            </a:pPr>
+            <a:r>
+              <a:rPr sz="1200">
+                <a:solidFill>
+                  <a:srgbClr val="1A1A1A"/>
+                </a:solidFill>
+                <a:latin typeface="Calibri"/>
+              </a:rPr>
+              <a:t>[8] D. Hoiem, A. A. Efros and M. Hebert, “Putting objects in perspective,” IJCV, vol. 80, no. 1, 2008.</a:t>
+            </a:r>
+          </a:p>
+          <a:p>
+            <a:pPr>
+              <a:spcAft>
+                <a:spcPts val="700"/>
+              </a:spcAft>
+            </a:pPr>
+            <a:r>
+              <a:rPr sz="1200">
+                <a:solidFill>
+                  <a:srgbClr val="1A1A1A"/>
+                </a:solidFill>
+                <a:latin typeface="Calibri"/>
+              </a:rPr>
+              <a:t>[9] L. Jin et al., “Perspective fields for single image camera calibration,” CVPR, 2023.</a:t>
+            </a:r>
+          </a:p>
+          <a:p>
+            <a:pPr>
+              <a:spcAft>
+                <a:spcPts val="700"/>
+              </a:spcAft>
+            </a:pPr>
+            <a:r>
+              <a:rPr sz="1200">
+                <a:solidFill>
+                  <a:srgbClr val="1A1A1A"/>
+                </a:solidFill>
+                <a:latin typeface="Calibri"/>
+              </a:rPr>
+              <a:t>[10] D. Podell et al., “SDXL: improving latent diffusion models for high-resolution image synthesis,” ICLR, 2024.</a:t>
+            </a:r>
+          </a:p>
+          <a:p>
+            <a:pPr>
+              <a:spcAft>
+                <a:spcPts val="700"/>
+              </a:spcAft>
+            </a:pPr>
+            <a:r>
+              <a:rPr sz="1200">
+                <a:solidFill>
+                  <a:srgbClr val="1A1A1A"/>
+                </a:solidFill>
+                <a:latin typeface="Calibri"/>
+              </a:rPr>
+              <a:t>[11] R. Rombach et al., “High-resolution image synthesis with latent diffusion models,” CVPR, 2022.</a:t>
+            </a:r>
+          </a:p>
+        </p:txBody>
+      </p:sp>
+      <p:sp>
+        <p:nvSpPr>
+          <p:cNvPr id="5" name="TextBox 4"/>
+          <p:cNvSpPr txBox="1"/>
+          <p:nvPr/>
+        </p:nvSpPr>
+        <p:spPr>
+          <a:xfrm>
+            <a:off x="640080" y="6309360"/>
+            <a:ext cx="10908792" cy="365760"/>
+          </a:xfrm>
+          <a:prstGeom prst="rect">
+            <a:avLst/>
+          </a:prstGeom>
+          <a:noFill/>
+        </p:spPr>
+        <p:txBody>
+          <a:bodyPr wrap="square" lIns="0" rIns="0" tIns="0" bIns="0" anchor="t">
+            <a:spAutoFit/>
+          </a:bodyPr>
+          <a:lstStyle/>
+          <a:p>
+            <a:pPr algn="l">
+              <a:spcAft>
+                <a:spcPts val="600"/>
+              </a:spcAft>
+            </a:pPr>
+            <a:r>
+              <a:rPr sz="1100" b="0" i="1">
+                <a:solidFill>
+                  <a:srgbClr val="5A6672"/>
+                </a:solidFill>
+                <a:latin typeface="Calibri"/>
+              </a:rPr>
+              <a:t>Dataset credits: York Urban Database (Elder Laboratory, York University); Wikimedia Commons photographs under CC licences, per-image attribution in the project metadata.</a:t>
             </a:r>
           </a:p>
         </p:txBody>

</xml_diff>